<commit_message>
Fixed how score 3 is calculated
</commit_message>
<xml_diff>
--- a/limb_position.pptx
+++ b/limb_position.pptx
@@ -7,6 +7,7 @@
   <p:sldIdLst>
     <p:sldId id="256" r:id="rId2"/>
     <p:sldId id="260" r:id="rId3"/>
+    <p:sldId id="261" r:id="rId4"/>
   </p:sldIdLst>
   <p:sldSz cx="12192000" cy="6858000"/>
   <p:notesSz cx="6858000" cy="9144000"/>
@@ -4331,6 +4332,518 @@
 </p:sld>
 </file>
 
+<file path=ppt/slides/slide3.xml><?xml version="1.0" encoding="utf-8"?>
+<p:sld xmlns:a="http://schemas.openxmlformats.org/drawingml/2006/main" xmlns:r="http://schemas.openxmlformats.org/officeDocument/2006/relationships" xmlns:p="http://schemas.openxmlformats.org/presentationml/2006/main">
+  <p:cSld>
+    <p:spTree>
+      <p:nvGrpSpPr>
+        <p:cNvPr id="1" name=""/>
+        <p:cNvGrpSpPr/>
+        <p:nvPr/>
+      </p:nvGrpSpPr>
+      <p:grpSpPr>
+        <a:xfrm>
+          <a:off x="0" y="0"/>
+          <a:ext cx="0" cy="0"/>
+          <a:chOff x="0" y="0"/>
+          <a:chExt cx="0" cy="0"/>
+        </a:xfrm>
+      </p:grpSpPr>
+      <p:sp>
+        <p:nvSpPr>
+          <p:cNvPr id="15" name="Oval 14">
+            <a:extLst>
+              <a:ext uri="{FF2B5EF4-FFF2-40B4-BE49-F238E27FC236}">
+                <a16:creationId xmlns:a16="http://schemas.microsoft.com/office/drawing/2014/main" id="{F9F5861D-FC12-C847-B65F-E6A6F6B44852}"/>
+              </a:ext>
+            </a:extLst>
+          </p:cNvPr>
+          <p:cNvSpPr/>
+          <p:nvPr/>
+        </p:nvSpPr>
+        <p:spPr>
+          <a:xfrm rot="14260250">
+            <a:off x="5053089" y="3161144"/>
+            <a:ext cx="510962" cy="549916"/>
+          </a:xfrm>
+          <a:prstGeom prst="ellipse">
+            <a:avLst/>
+          </a:prstGeom>
+        </p:spPr>
+        <p:style>
+          <a:lnRef idx="1">
+            <a:schemeClr val="dk1"/>
+          </a:lnRef>
+          <a:fillRef idx="2">
+            <a:schemeClr val="dk1"/>
+          </a:fillRef>
+          <a:effectRef idx="1">
+            <a:schemeClr val="dk1"/>
+          </a:effectRef>
+          <a:fontRef idx="minor">
+            <a:schemeClr val="dk1"/>
+          </a:fontRef>
+        </p:style>
+        <p:txBody>
+          <a:bodyPr rot="0" spcFirstLastPara="0" vertOverflow="overflow" horzOverflow="overflow" vert="horz" wrap="square" lIns="91440" tIns="45720" rIns="91440" bIns="45720" numCol="1" spcCol="0" rtlCol="0" fromWordArt="0" anchor="ctr" anchorCtr="0" forceAA="0" compatLnSpc="1">
+            <a:prstTxWarp prst="textNoShape">
+              <a:avLst/>
+            </a:prstTxWarp>
+            <a:noAutofit/>
+          </a:bodyPr>
+          <a:lstStyle/>
+          <a:p>
+            <a:pPr algn="ctr"/>
+            <a:endParaRPr lang="en-US"/>
+          </a:p>
+        </p:txBody>
+      </p:sp>
+      <p:grpSp>
+        <p:nvGrpSpPr>
+          <p:cNvPr id="2" name="Group 1">
+            <a:extLst>
+              <a:ext uri="{FF2B5EF4-FFF2-40B4-BE49-F238E27FC236}">
+                <a16:creationId xmlns:a16="http://schemas.microsoft.com/office/drawing/2014/main" id="{17F43047-9720-1F45-A89E-A9C8A612D0A8}"/>
+              </a:ext>
+            </a:extLst>
+          </p:cNvPr>
+          <p:cNvGrpSpPr/>
+          <p:nvPr/>
+        </p:nvGrpSpPr>
+        <p:grpSpPr>
+          <a:xfrm>
+            <a:off x="4442586" y="2036190"/>
+            <a:ext cx="1171575" cy="1833165"/>
+            <a:chOff x="4442586" y="2036190"/>
+            <a:chExt cx="1171575" cy="1833165"/>
+          </a:xfrm>
+        </p:grpSpPr>
+        <p:sp>
+          <p:nvSpPr>
+            <p:cNvPr id="67" name="Oval 66">
+              <a:extLst>
+                <a:ext uri="{FF2B5EF4-FFF2-40B4-BE49-F238E27FC236}">
+                  <a16:creationId xmlns:a16="http://schemas.microsoft.com/office/drawing/2014/main" id="{F50C8471-61EC-BE4C-9F35-C7A559211D01}"/>
+                </a:ext>
+              </a:extLst>
+            </p:cNvPr>
+            <p:cNvSpPr/>
+            <p:nvPr/>
+          </p:nvSpPr>
+          <p:spPr>
+            <a:xfrm rot="7339750" flipH="1">
+              <a:off x="4529700" y="3154597"/>
+              <a:ext cx="510962" cy="549916"/>
+            </a:xfrm>
+            <a:prstGeom prst="ellipse">
+              <a:avLst/>
+            </a:prstGeom>
+          </p:spPr>
+          <p:style>
+            <a:lnRef idx="1">
+              <a:schemeClr val="dk1"/>
+            </a:lnRef>
+            <a:fillRef idx="2">
+              <a:schemeClr val="dk1"/>
+            </a:fillRef>
+            <a:effectRef idx="1">
+              <a:schemeClr val="dk1"/>
+            </a:effectRef>
+            <a:fontRef idx="minor">
+              <a:schemeClr val="dk1"/>
+            </a:fontRef>
+          </p:style>
+          <p:txBody>
+            <a:bodyPr rot="0" spcFirstLastPara="0" vertOverflow="overflow" horzOverflow="overflow" vert="horz" wrap="square" lIns="91440" tIns="45720" rIns="91440" bIns="45720" numCol="1" spcCol="0" rtlCol="0" fromWordArt="0" anchor="ctr" anchorCtr="0" forceAA="0" compatLnSpc="1">
+              <a:prstTxWarp prst="textNoShape">
+                <a:avLst/>
+              </a:prstTxWarp>
+              <a:noAutofit/>
+            </a:bodyPr>
+            <a:lstStyle/>
+            <a:p>
+              <a:pPr algn="ctr"/>
+              <a:endParaRPr lang="en-US"/>
+            </a:p>
+          </p:txBody>
+        </p:sp>
+        <p:sp>
+          <p:nvSpPr>
+            <p:cNvPr id="55" name="Triangle 54">
+              <a:extLst>
+                <a:ext uri="{FF2B5EF4-FFF2-40B4-BE49-F238E27FC236}">
+                  <a16:creationId xmlns:a16="http://schemas.microsoft.com/office/drawing/2014/main" id="{F1AA8FBF-5A5E-4947-9BF4-87EAFBF92066}"/>
+                </a:ext>
+              </a:extLst>
+            </p:cNvPr>
+            <p:cNvSpPr/>
+            <p:nvPr/>
+          </p:nvSpPr>
+          <p:spPr>
+            <a:xfrm rot="10800000" flipH="1">
+              <a:off x="4442586" y="2384981"/>
+              <a:ext cx="1171575" cy="1484374"/>
+            </a:xfrm>
+            <a:prstGeom prst="triangle">
+              <a:avLst/>
+            </a:prstGeom>
+          </p:spPr>
+          <p:style>
+            <a:lnRef idx="1">
+              <a:schemeClr val="dk1"/>
+            </a:lnRef>
+            <a:fillRef idx="2">
+              <a:schemeClr val="dk1"/>
+            </a:fillRef>
+            <a:effectRef idx="1">
+              <a:schemeClr val="dk1"/>
+            </a:effectRef>
+            <a:fontRef idx="minor">
+              <a:schemeClr val="dk1"/>
+            </a:fontRef>
+          </p:style>
+          <p:txBody>
+            <a:bodyPr rtlCol="0" anchor="ctr"/>
+            <a:lstStyle/>
+            <a:p>
+              <a:pPr algn="ctr"/>
+              <a:endParaRPr lang="en-US" dirty="0"/>
+            </a:p>
+          </p:txBody>
+        </p:sp>
+        <p:sp>
+          <p:nvSpPr>
+            <p:cNvPr id="56" name="Can 55">
+              <a:extLst>
+                <a:ext uri="{FF2B5EF4-FFF2-40B4-BE49-F238E27FC236}">
+                  <a16:creationId xmlns:a16="http://schemas.microsoft.com/office/drawing/2014/main" id="{AAC1A6EF-A8F8-F44A-A4DF-6CB5A4ABD55D}"/>
+                </a:ext>
+              </a:extLst>
+            </p:cNvPr>
+            <p:cNvSpPr/>
+            <p:nvPr/>
+          </p:nvSpPr>
+          <p:spPr>
+            <a:xfrm rot="8840046">
+              <a:off x="4672510" y="2407337"/>
+              <a:ext cx="385763" cy="726819"/>
+            </a:xfrm>
+            <a:prstGeom prst="can">
+              <a:avLst/>
+            </a:prstGeom>
+          </p:spPr>
+          <p:style>
+            <a:lnRef idx="2">
+              <a:schemeClr val="accent1">
+                <a:shade val="50000"/>
+              </a:schemeClr>
+            </a:lnRef>
+            <a:fillRef idx="1">
+              <a:schemeClr val="accent1"/>
+            </a:fillRef>
+            <a:effectRef idx="0">
+              <a:schemeClr val="accent1"/>
+            </a:effectRef>
+            <a:fontRef idx="minor">
+              <a:schemeClr val="lt1"/>
+            </a:fontRef>
+          </p:style>
+          <p:txBody>
+            <a:bodyPr rtlCol="0" anchor="ctr"/>
+            <a:lstStyle/>
+            <a:p>
+              <a:pPr algn="ctr"/>
+              <a:endParaRPr lang="en-US" dirty="0"/>
+            </a:p>
+          </p:txBody>
+        </p:sp>
+        <p:cxnSp>
+          <p:nvCxnSpPr>
+            <p:cNvPr id="71" name="Straight Connector 70">
+              <a:extLst>
+                <a:ext uri="{FF2B5EF4-FFF2-40B4-BE49-F238E27FC236}">
+                  <a16:creationId xmlns:a16="http://schemas.microsoft.com/office/drawing/2014/main" id="{0A219D18-D9D9-E343-8FC4-989F88AA51F0}"/>
+                </a:ext>
+              </a:extLst>
+            </p:cNvPr>
+            <p:cNvCxnSpPr/>
+            <p:nvPr/>
+          </p:nvCxnSpPr>
+          <p:spPr>
+            <a:xfrm>
+              <a:off x="5034642" y="3530586"/>
+              <a:ext cx="0" cy="108160"/>
+            </a:xfrm>
+            <a:prstGeom prst="line">
+              <a:avLst/>
+            </a:prstGeom>
+            <a:ln w="38100">
+              <a:solidFill>
+                <a:schemeClr val="bg1"/>
+              </a:solidFill>
+            </a:ln>
+          </p:spPr>
+          <p:style>
+            <a:lnRef idx="1">
+              <a:schemeClr val="accent1"/>
+            </a:lnRef>
+            <a:fillRef idx="0">
+              <a:schemeClr val="accent1"/>
+            </a:fillRef>
+            <a:effectRef idx="0">
+              <a:schemeClr val="accent1"/>
+            </a:effectRef>
+            <a:fontRef idx="minor">
+              <a:schemeClr val="tx1"/>
+            </a:fontRef>
+          </p:style>
+        </p:cxnSp>
+        <p:cxnSp>
+          <p:nvCxnSpPr>
+            <p:cNvPr id="72" name="Straight Connector 71">
+              <a:extLst>
+                <a:ext uri="{FF2B5EF4-FFF2-40B4-BE49-F238E27FC236}">
+                  <a16:creationId xmlns:a16="http://schemas.microsoft.com/office/drawing/2014/main" id="{FC1B5090-4092-4145-BF1A-DED9FEF6618F}"/>
+                </a:ext>
+              </a:extLst>
+            </p:cNvPr>
+            <p:cNvCxnSpPr>
+              <a:cxnSpLocks/>
+            </p:cNvCxnSpPr>
+            <p:nvPr/>
+          </p:nvCxnSpPr>
+          <p:spPr>
+            <a:xfrm>
+              <a:off x="4933488" y="3469736"/>
+              <a:ext cx="101154" cy="65947"/>
+            </a:xfrm>
+            <a:prstGeom prst="line">
+              <a:avLst/>
+            </a:prstGeom>
+            <a:ln w="38100">
+              <a:solidFill>
+                <a:schemeClr val="bg1"/>
+              </a:solidFill>
+            </a:ln>
+          </p:spPr>
+          <p:style>
+            <a:lnRef idx="1">
+              <a:schemeClr val="accent1"/>
+            </a:lnRef>
+            <a:fillRef idx="0">
+              <a:schemeClr val="accent1"/>
+            </a:fillRef>
+            <a:effectRef idx="0">
+              <a:schemeClr val="accent1"/>
+            </a:effectRef>
+            <a:fontRef idx="minor">
+              <a:schemeClr val="tx1"/>
+            </a:fontRef>
+          </p:style>
+        </p:cxnSp>
+        <p:cxnSp>
+          <p:nvCxnSpPr>
+            <p:cNvPr id="75" name="Straight Connector 74">
+              <a:extLst>
+                <a:ext uri="{FF2B5EF4-FFF2-40B4-BE49-F238E27FC236}">
+                  <a16:creationId xmlns:a16="http://schemas.microsoft.com/office/drawing/2014/main" id="{25B56C43-9DDC-2E43-8BED-179D4E652E41}"/>
+                </a:ext>
+              </a:extLst>
+            </p:cNvPr>
+            <p:cNvCxnSpPr>
+              <a:cxnSpLocks/>
+            </p:cNvCxnSpPr>
+            <p:nvPr/>
+          </p:nvCxnSpPr>
+          <p:spPr>
+            <a:xfrm flipH="1">
+              <a:off x="5034642" y="3469735"/>
+              <a:ext cx="101154" cy="65947"/>
+            </a:xfrm>
+            <a:prstGeom prst="line">
+              <a:avLst/>
+            </a:prstGeom>
+            <a:ln w="38100">
+              <a:solidFill>
+                <a:schemeClr val="bg1"/>
+              </a:solidFill>
+            </a:ln>
+          </p:spPr>
+          <p:style>
+            <a:lnRef idx="1">
+              <a:schemeClr val="accent1"/>
+            </a:lnRef>
+            <a:fillRef idx="0">
+              <a:schemeClr val="accent1"/>
+            </a:fillRef>
+            <a:effectRef idx="0">
+              <a:schemeClr val="accent1"/>
+            </a:effectRef>
+            <a:fontRef idx="minor">
+              <a:schemeClr val="tx1"/>
+            </a:fontRef>
+          </p:style>
+        </p:cxnSp>
+        <p:cxnSp>
+          <p:nvCxnSpPr>
+            <p:cNvPr id="91" name="Straight Connector 90">
+              <a:extLst>
+                <a:ext uri="{FF2B5EF4-FFF2-40B4-BE49-F238E27FC236}">
+                  <a16:creationId xmlns:a16="http://schemas.microsoft.com/office/drawing/2014/main" id="{609D9B8B-55A7-0445-BFC5-420BCDEB5FAC}"/>
+                </a:ext>
+              </a:extLst>
+            </p:cNvPr>
+            <p:cNvCxnSpPr>
+              <a:cxnSpLocks/>
+              <a:stCxn id="55" idx="3"/>
+            </p:cNvCxnSpPr>
+            <p:nvPr/>
+          </p:nvCxnSpPr>
+          <p:spPr>
+            <a:xfrm flipV="1">
+              <a:off x="5028374" y="2036190"/>
+              <a:ext cx="0" cy="348791"/>
+            </a:xfrm>
+            <a:prstGeom prst="line">
+              <a:avLst/>
+            </a:prstGeom>
+            <a:ln w="38100">
+              <a:solidFill>
+                <a:schemeClr val="bg1">
+                  <a:lumMod val="50000"/>
+                </a:schemeClr>
+              </a:solidFill>
+            </a:ln>
+          </p:spPr>
+          <p:style>
+            <a:lnRef idx="1">
+              <a:schemeClr val="dk1"/>
+            </a:lnRef>
+            <a:fillRef idx="2">
+              <a:schemeClr val="dk1"/>
+            </a:fillRef>
+            <a:effectRef idx="1">
+              <a:schemeClr val="dk1"/>
+            </a:effectRef>
+            <a:fontRef idx="minor">
+              <a:schemeClr val="dk1"/>
+            </a:fontRef>
+          </p:style>
+        </p:cxnSp>
+      </p:grpSp>
+      <p:sp>
+        <p:nvSpPr>
+          <p:cNvPr id="13" name="Rectangle 12">
+            <a:extLst>
+              <a:ext uri="{FF2B5EF4-FFF2-40B4-BE49-F238E27FC236}">
+                <a16:creationId xmlns:a16="http://schemas.microsoft.com/office/drawing/2014/main" id="{20CDBE0E-CBDD-514C-B02A-D79DBD9A49DB}"/>
+              </a:ext>
+            </a:extLst>
+          </p:cNvPr>
+          <p:cNvSpPr/>
+          <p:nvPr/>
+        </p:nvSpPr>
+        <p:spPr>
+          <a:xfrm>
+            <a:off x="4387090" y="1999215"/>
+            <a:ext cx="1275230" cy="1947464"/>
+          </a:xfrm>
+          <a:prstGeom prst="rect">
+            <a:avLst/>
+          </a:prstGeom>
+          <a:noFill/>
+          <a:ln>
+            <a:solidFill>
+              <a:schemeClr val="bg1">
+                <a:lumMod val="85000"/>
+              </a:schemeClr>
+            </a:solidFill>
+          </a:ln>
+        </p:spPr>
+        <p:style>
+          <a:lnRef idx="2">
+            <a:schemeClr val="accent1">
+              <a:shade val="50000"/>
+            </a:schemeClr>
+          </a:lnRef>
+          <a:fillRef idx="1">
+            <a:schemeClr val="accent1"/>
+          </a:fillRef>
+          <a:effectRef idx="0">
+            <a:schemeClr val="accent1"/>
+          </a:effectRef>
+          <a:fontRef idx="minor">
+            <a:schemeClr val="lt1"/>
+          </a:fontRef>
+        </p:style>
+        <p:txBody>
+          <a:bodyPr rtlCol="0" anchor="ctr"/>
+          <a:lstStyle/>
+          <a:p>
+            <a:pPr algn="ctr"/>
+            <a:endParaRPr lang="en-US"/>
+          </a:p>
+        </p:txBody>
+      </p:sp>
+      <p:sp>
+        <p:nvSpPr>
+          <p:cNvPr id="14" name="Can 13">
+            <a:extLst>
+              <a:ext uri="{FF2B5EF4-FFF2-40B4-BE49-F238E27FC236}">
+                <a16:creationId xmlns:a16="http://schemas.microsoft.com/office/drawing/2014/main" id="{DC973840-68CC-DC4E-AFAC-F72C4A38020E}"/>
+              </a:ext>
+            </a:extLst>
+          </p:cNvPr>
+          <p:cNvSpPr/>
+          <p:nvPr/>
+        </p:nvSpPr>
+        <p:spPr>
+          <a:xfrm rot="12759954" flipH="1">
+            <a:off x="4970940" y="2416315"/>
+            <a:ext cx="385763" cy="726819"/>
+          </a:xfrm>
+          <a:prstGeom prst="can">
+            <a:avLst/>
+          </a:prstGeom>
+        </p:spPr>
+        <p:style>
+          <a:lnRef idx="2">
+            <a:schemeClr val="accent1">
+              <a:shade val="50000"/>
+            </a:schemeClr>
+          </a:lnRef>
+          <a:fillRef idx="1">
+            <a:schemeClr val="accent1"/>
+          </a:fillRef>
+          <a:effectRef idx="0">
+            <a:schemeClr val="accent1"/>
+          </a:effectRef>
+          <a:fontRef idx="minor">
+            <a:schemeClr val="lt1"/>
+          </a:fontRef>
+        </p:style>
+        <p:txBody>
+          <a:bodyPr rtlCol="0" anchor="ctr"/>
+          <a:lstStyle/>
+          <a:p>
+            <a:pPr algn="ctr"/>
+            <a:endParaRPr lang="en-US" dirty="0"/>
+          </a:p>
+        </p:txBody>
+      </p:sp>
+    </p:spTree>
+    <p:extLst>
+      <p:ext uri="{BB962C8B-B14F-4D97-AF65-F5344CB8AC3E}">
+        <p14:creationId xmlns:p14="http://schemas.microsoft.com/office/powerpoint/2010/main" val="880446613"/>
+      </p:ext>
+    </p:extLst>
+  </p:cSld>
+  <p:clrMapOvr>
+    <a:masterClrMapping/>
+  </p:clrMapOvr>
+</p:sld>
+</file>
+
 <file path=ppt/theme/theme1.xml><?xml version="1.0" encoding="utf-8"?>
 <a:theme xmlns:a="http://schemas.openxmlformats.org/drawingml/2006/main" name="Office Theme">
   <a:themeElements>

</xml_diff>

<commit_message>
Ads hint about angle.
</commit_message>
<xml_diff>
--- a/limb_position.pptx
+++ b/limb_position.pptx
@@ -3779,6 +3779,536 @@
           </a:p>
         </p:txBody>
       </p:sp>
+      <p:sp>
+        <p:nvSpPr>
+          <p:cNvPr id="32" name="Rectangle 31">
+            <a:extLst>
+              <a:ext uri="{FF2B5EF4-FFF2-40B4-BE49-F238E27FC236}">
+                <a16:creationId xmlns:a16="http://schemas.microsoft.com/office/drawing/2014/main" id="{CF8B86DC-52DB-6341-A749-C3C4243F319E}"/>
+              </a:ext>
+            </a:extLst>
+          </p:cNvPr>
+          <p:cNvSpPr/>
+          <p:nvPr/>
+        </p:nvSpPr>
+        <p:spPr>
+          <a:xfrm>
+            <a:off x="5676717" y="1989054"/>
+            <a:ext cx="1305235" cy="1300909"/>
+          </a:xfrm>
+          <a:prstGeom prst="rect">
+            <a:avLst/>
+          </a:prstGeom>
+          <a:noFill/>
+          <a:ln>
+            <a:solidFill>
+              <a:schemeClr val="bg1">
+                <a:lumMod val="85000"/>
+              </a:schemeClr>
+            </a:solidFill>
+          </a:ln>
+        </p:spPr>
+        <p:style>
+          <a:lnRef idx="2">
+            <a:schemeClr val="accent1">
+              <a:shade val="50000"/>
+            </a:schemeClr>
+          </a:lnRef>
+          <a:fillRef idx="1">
+            <a:schemeClr val="accent1"/>
+          </a:fillRef>
+          <a:effectRef idx="0">
+            <a:schemeClr val="accent1"/>
+          </a:effectRef>
+          <a:fontRef idx="minor">
+            <a:schemeClr val="lt1"/>
+          </a:fontRef>
+        </p:style>
+        <p:txBody>
+          <a:bodyPr rtlCol="0" anchor="ctr"/>
+          <a:lstStyle/>
+          <a:p>
+            <a:pPr algn="ctr"/>
+            <a:endParaRPr lang="en-US"/>
+          </a:p>
+        </p:txBody>
+      </p:sp>
+      <p:grpSp>
+        <p:nvGrpSpPr>
+          <p:cNvPr id="18" name="Group 17">
+            <a:extLst>
+              <a:ext uri="{FF2B5EF4-FFF2-40B4-BE49-F238E27FC236}">
+                <a16:creationId xmlns:a16="http://schemas.microsoft.com/office/drawing/2014/main" id="{019EDFD7-420F-604D-B24D-5469DD77AE9B}"/>
+              </a:ext>
+            </a:extLst>
+          </p:cNvPr>
+          <p:cNvGrpSpPr/>
+          <p:nvPr/>
+        </p:nvGrpSpPr>
+        <p:grpSpPr>
+          <a:xfrm>
+            <a:off x="5645503" y="2251236"/>
+            <a:ext cx="1403050" cy="1057913"/>
+            <a:chOff x="5645503" y="2263428"/>
+            <a:chExt cx="1403050" cy="1057913"/>
+          </a:xfrm>
+        </p:grpSpPr>
+        <p:grpSp>
+          <p:nvGrpSpPr>
+            <p:cNvPr id="17" name="Group 16">
+              <a:extLst>
+                <a:ext uri="{FF2B5EF4-FFF2-40B4-BE49-F238E27FC236}">
+                  <a16:creationId xmlns:a16="http://schemas.microsoft.com/office/drawing/2014/main" id="{8A51DF10-22D3-664B-849A-B96A7B3D4350}"/>
+                </a:ext>
+              </a:extLst>
+            </p:cNvPr>
+            <p:cNvGrpSpPr/>
+            <p:nvPr/>
+          </p:nvGrpSpPr>
+          <p:grpSpPr>
+            <a:xfrm>
+              <a:off x="5645503" y="2398011"/>
+              <a:ext cx="1403050" cy="832920"/>
+              <a:chOff x="5682959" y="2430398"/>
+              <a:chExt cx="1403050" cy="832920"/>
+            </a:xfrm>
+          </p:grpSpPr>
+          <p:cxnSp>
+            <p:nvCxnSpPr>
+              <p:cNvPr id="34" name="Straight Connector 33">
+                <a:extLst>
+                  <a:ext uri="{FF2B5EF4-FFF2-40B4-BE49-F238E27FC236}">
+                    <a16:creationId xmlns:a16="http://schemas.microsoft.com/office/drawing/2014/main" id="{C1410969-735C-694E-B831-939487DDDB06}"/>
+                  </a:ext>
+                </a:extLst>
+              </p:cNvPr>
+              <p:cNvCxnSpPr>
+                <a:cxnSpLocks/>
+              </p:cNvCxnSpPr>
+              <p:nvPr/>
+            </p:nvCxnSpPr>
+            <p:spPr>
+              <a:xfrm flipH="1">
+                <a:off x="5851470" y="2615124"/>
+                <a:ext cx="360000" cy="0"/>
+              </a:xfrm>
+              <a:prstGeom prst="line">
+                <a:avLst/>
+              </a:prstGeom>
+              <a:ln w="28575">
+                <a:solidFill>
+                  <a:srgbClr val="FF0000"/>
+                </a:solidFill>
+                <a:prstDash val="solid"/>
+              </a:ln>
+            </p:spPr>
+            <p:style>
+              <a:lnRef idx="1">
+                <a:schemeClr val="accent1"/>
+              </a:lnRef>
+              <a:fillRef idx="0">
+                <a:schemeClr val="accent1"/>
+              </a:fillRef>
+              <a:effectRef idx="0">
+                <a:schemeClr val="accent1"/>
+              </a:effectRef>
+              <a:fontRef idx="minor">
+                <a:schemeClr val="tx1"/>
+              </a:fontRef>
+            </p:style>
+          </p:cxnSp>
+          <p:cxnSp>
+            <p:nvCxnSpPr>
+              <p:cNvPr id="37" name="Straight Connector 36">
+                <a:extLst>
+                  <a:ext uri="{FF2B5EF4-FFF2-40B4-BE49-F238E27FC236}">
+                    <a16:creationId xmlns:a16="http://schemas.microsoft.com/office/drawing/2014/main" id="{42C5F916-DAA3-BF4C-B0A3-D37EEE3A92A8}"/>
+                  </a:ext>
+                </a:extLst>
+              </p:cNvPr>
+              <p:cNvCxnSpPr>
+                <a:cxnSpLocks/>
+              </p:cNvCxnSpPr>
+              <p:nvPr/>
+            </p:nvCxnSpPr>
+            <p:spPr>
+              <a:xfrm flipV="1">
+                <a:off x="6223671" y="2600201"/>
+                <a:ext cx="0" cy="360000"/>
+              </a:xfrm>
+              <a:prstGeom prst="line">
+                <a:avLst/>
+              </a:prstGeom>
+              <a:ln w="28575">
+                <a:solidFill>
+                  <a:schemeClr val="tx1"/>
+                </a:solidFill>
+                <a:prstDash val="solid"/>
+              </a:ln>
+            </p:spPr>
+            <p:style>
+              <a:lnRef idx="1">
+                <a:schemeClr val="accent1"/>
+              </a:lnRef>
+              <a:fillRef idx="0">
+                <a:schemeClr val="accent1"/>
+              </a:fillRef>
+              <a:effectRef idx="0">
+                <a:schemeClr val="accent1"/>
+              </a:effectRef>
+              <a:fontRef idx="minor">
+                <a:schemeClr val="tx1"/>
+              </a:fontRef>
+            </p:style>
+          </p:cxnSp>
+          <p:sp>
+            <p:nvSpPr>
+              <p:cNvPr id="12" name="TextBox 11">
+                <a:extLst>
+                  <a:ext uri="{FF2B5EF4-FFF2-40B4-BE49-F238E27FC236}">
+                    <a16:creationId xmlns:a16="http://schemas.microsoft.com/office/drawing/2014/main" id="{F0E1D980-FDE6-764E-AC6B-7A917BE198E2}"/>
+                  </a:ext>
+                </a:extLst>
+              </p:cNvPr>
+              <p:cNvSpPr txBox="1"/>
+              <p:nvPr/>
+            </p:nvSpPr>
+            <p:spPr>
+              <a:xfrm>
+                <a:off x="6024824" y="2893986"/>
+                <a:ext cx="418704" cy="369332"/>
+              </a:xfrm>
+              <a:prstGeom prst="rect">
+                <a:avLst/>
+              </a:prstGeom>
+              <a:noFill/>
+            </p:spPr>
+            <p:txBody>
+              <a:bodyPr wrap="none" rtlCol="0">
+                <a:spAutoFit/>
+              </a:bodyPr>
+              <a:lstStyle/>
+              <a:p>
+                <a:r>
+                  <a:rPr lang="en-US" dirty="0"/>
+                  <a:t>90</a:t>
+                </a:r>
+              </a:p>
+            </p:txBody>
+          </p:sp>
+          <p:cxnSp>
+            <p:nvCxnSpPr>
+              <p:cNvPr id="41" name="Straight Connector 40">
+                <a:extLst>
+                  <a:ext uri="{FF2B5EF4-FFF2-40B4-BE49-F238E27FC236}">
+                    <a16:creationId xmlns:a16="http://schemas.microsoft.com/office/drawing/2014/main" id="{9E35AE0E-BD74-FB43-83C0-B38D20C2F6CF}"/>
+                  </a:ext>
+                </a:extLst>
+              </p:cNvPr>
+              <p:cNvCxnSpPr>
+                <a:cxnSpLocks/>
+              </p:cNvCxnSpPr>
+              <p:nvPr/>
+            </p:nvCxnSpPr>
+            <p:spPr>
+              <a:xfrm flipH="1">
+                <a:off x="6217920" y="2615064"/>
+                <a:ext cx="360000" cy="0"/>
+              </a:xfrm>
+              <a:prstGeom prst="line">
+                <a:avLst/>
+              </a:prstGeom>
+              <a:ln w="28575">
+                <a:solidFill>
+                  <a:schemeClr val="tx1"/>
+                </a:solidFill>
+                <a:prstDash val="solid"/>
+              </a:ln>
+            </p:spPr>
+            <p:style>
+              <a:lnRef idx="1">
+                <a:schemeClr val="accent1"/>
+              </a:lnRef>
+              <a:fillRef idx="0">
+                <a:schemeClr val="accent1"/>
+              </a:fillRef>
+              <a:effectRef idx="0">
+                <a:schemeClr val="accent1"/>
+              </a:effectRef>
+              <a:fontRef idx="minor">
+                <a:schemeClr val="tx1"/>
+              </a:fontRef>
+            </p:style>
+          </p:cxnSp>
+          <p:sp>
+            <p:nvSpPr>
+              <p:cNvPr id="42" name="TextBox 41">
+                <a:extLst>
+                  <a:ext uri="{FF2B5EF4-FFF2-40B4-BE49-F238E27FC236}">
+                    <a16:creationId xmlns:a16="http://schemas.microsoft.com/office/drawing/2014/main" id="{3880AAD5-2790-6D42-A0BB-8402E084E29A}"/>
+                  </a:ext>
+                </a:extLst>
+              </p:cNvPr>
+              <p:cNvSpPr txBox="1"/>
+              <p:nvPr/>
+            </p:nvSpPr>
+            <p:spPr>
+              <a:xfrm>
+                <a:off x="6550285" y="2430398"/>
+                <a:ext cx="535724" cy="369332"/>
+              </a:xfrm>
+              <a:prstGeom prst="rect">
+                <a:avLst/>
+              </a:prstGeom>
+              <a:noFill/>
+            </p:spPr>
+            <p:txBody>
+              <a:bodyPr wrap="none" rtlCol="0">
+                <a:spAutoFit/>
+              </a:bodyPr>
+              <a:lstStyle/>
+              <a:p>
+                <a:r>
+                  <a:rPr lang="en-US" dirty="0"/>
+                  <a:t>180</a:t>
+                </a:r>
+              </a:p>
+            </p:txBody>
+          </p:sp>
+          <p:cxnSp>
+            <p:nvCxnSpPr>
+              <p:cNvPr id="44" name="Straight Connector 43">
+                <a:extLst>
+                  <a:ext uri="{FF2B5EF4-FFF2-40B4-BE49-F238E27FC236}">
+                    <a16:creationId xmlns:a16="http://schemas.microsoft.com/office/drawing/2014/main" id="{8BD201C1-DDB2-B14F-BD6E-CBC2310E902A}"/>
+                  </a:ext>
+                </a:extLst>
+              </p:cNvPr>
+              <p:cNvCxnSpPr>
+                <a:cxnSpLocks/>
+              </p:cNvCxnSpPr>
+              <p:nvPr/>
+            </p:nvCxnSpPr>
+            <p:spPr>
+              <a:xfrm rot="2700000" flipV="1">
+                <a:off x="6088170" y="2574496"/>
+                <a:ext cx="0" cy="360000"/>
+              </a:xfrm>
+              <a:prstGeom prst="line">
+                <a:avLst/>
+              </a:prstGeom>
+              <a:ln w="28575">
+                <a:solidFill>
+                  <a:schemeClr val="tx1"/>
+                </a:solidFill>
+                <a:prstDash val="solid"/>
+              </a:ln>
+            </p:spPr>
+            <p:style>
+              <a:lnRef idx="1">
+                <a:schemeClr val="accent1"/>
+              </a:lnRef>
+              <a:fillRef idx="0">
+                <a:schemeClr val="accent1"/>
+              </a:fillRef>
+              <a:effectRef idx="0">
+                <a:schemeClr val="accent1"/>
+              </a:effectRef>
+              <a:fontRef idx="minor">
+                <a:schemeClr val="tx1"/>
+              </a:fontRef>
+            </p:style>
+          </p:cxnSp>
+          <p:sp>
+            <p:nvSpPr>
+              <p:cNvPr id="45" name="TextBox 44">
+                <a:extLst>
+                  <a:ext uri="{FF2B5EF4-FFF2-40B4-BE49-F238E27FC236}">
+                    <a16:creationId xmlns:a16="http://schemas.microsoft.com/office/drawing/2014/main" id="{DBD48DAB-5A75-4E47-B839-E5D110E14E3D}"/>
+                  </a:ext>
+                </a:extLst>
+              </p:cNvPr>
+              <p:cNvSpPr txBox="1"/>
+              <p:nvPr/>
+            </p:nvSpPr>
+            <p:spPr>
+              <a:xfrm>
+                <a:off x="5682959" y="2780201"/>
+                <a:ext cx="418704" cy="369332"/>
+              </a:xfrm>
+              <a:prstGeom prst="rect">
+                <a:avLst/>
+              </a:prstGeom>
+              <a:noFill/>
+            </p:spPr>
+            <p:txBody>
+              <a:bodyPr wrap="none" rtlCol="0">
+                <a:spAutoFit/>
+              </a:bodyPr>
+              <a:lstStyle/>
+              <a:p>
+                <a:r>
+                  <a:rPr lang="en-US" dirty="0"/>
+                  <a:t>45</a:t>
+                </a:r>
+              </a:p>
+            </p:txBody>
+          </p:sp>
+          <p:cxnSp>
+            <p:nvCxnSpPr>
+              <p:cNvPr id="46" name="Straight Connector 45">
+                <a:extLst>
+                  <a:ext uri="{FF2B5EF4-FFF2-40B4-BE49-F238E27FC236}">
+                    <a16:creationId xmlns:a16="http://schemas.microsoft.com/office/drawing/2014/main" id="{96B080D8-B1C2-BB4F-8C29-ECE21BBD4E65}"/>
+                  </a:ext>
+                </a:extLst>
+              </p:cNvPr>
+              <p:cNvCxnSpPr>
+                <a:cxnSpLocks/>
+              </p:cNvCxnSpPr>
+              <p:nvPr/>
+            </p:nvCxnSpPr>
+            <p:spPr>
+              <a:xfrm rot="18900000" flipH="1" flipV="1">
+                <a:off x="6349550" y="2571556"/>
+                <a:ext cx="0" cy="360000"/>
+              </a:xfrm>
+              <a:prstGeom prst="line">
+                <a:avLst/>
+              </a:prstGeom>
+              <a:ln w="28575">
+                <a:solidFill>
+                  <a:schemeClr val="tx1"/>
+                </a:solidFill>
+                <a:prstDash val="solid"/>
+              </a:ln>
+            </p:spPr>
+            <p:style>
+              <a:lnRef idx="1">
+                <a:schemeClr val="accent1"/>
+              </a:lnRef>
+              <a:fillRef idx="0">
+                <a:schemeClr val="accent1"/>
+              </a:fillRef>
+              <a:effectRef idx="0">
+                <a:schemeClr val="accent1"/>
+              </a:effectRef>
+              <a:fontRef idx="minor">
+                <a:schemeClr val="tx1"/>
+              </a:fontRef>
+            </p:style>
+          </p:cxnSp>
+          <p:sp>
+            <p:nvSpPr>
+              <p:cNvPr id="49" name="TextBox 48">
+                <a:extLst>
+                  <a:ext uri="{FF2B5EF4-FFF2-40B4-BE49-F238E27FC236}">
+                    <a16:creationId xmlns:a16="http://schemas.microsoft.com/office/drawing/2014/main" id="{32FEF30D-1D20-174C-BB89-A61C12708F41}"/>
+                  </a:ext>
+                </a:extLst>
+              </p:cNvPr>
+              <p:cNvSpPr txBox="1"/>
+              <p:nvPr/>
+            </p:nvSpPr>
+            <p:spPr>
+              <a:xfrm>
+                <a:off x="6399443" y="2784234"/>
+                <a:ext cx="535724" cy="369332"/>
+              </a:xfrm>
+              <a:prstGeom prst="rect">
+                <a:avLst/>
+              </a:prstGeom>
+              <a:noFill/>
+            </p:spPr>
+            <p:txBody>
+              <a:bodyPr wrap="none" rtlCol="0">
+                <a:spAutoFit/>
+              </a:bodyPr>
+              <a:lstStyle/>
+              <a:p>
+                <a:r>
+                  <a:rPr lang="en-US" dirty="0"/>
+                  <a:t>135</a:t>
+                </a:r>
+              </a:p>
+            </p:txBody>
+          </p:sp>
+        </p:grpSp>
+        <p:sp>
+          <p:nvSpPr>
+            <p:cNvPr id="50" name="TextBox 49">
+              <a:extLst>
+                <a:ext uri="{FF2B5EF4-FFF2-40B4-BE49-F238E27FC236}">
+                  <a16:creationId xmlns:a16="http://schemas.microsoft.com/office/drawing/2014/main" id="{8A12FA53-DCD5-0C4F-8629-0DA5EBF8EA85}"/>
+                </a:ext>
+              </a:extLst>
+            </p:cNvPr>
+            <p:cNvSpPr txBox="1"/>
+            <p:nvPr/>
+          </p:nvSpPr>
+          <p:spPr>
+            <a:xfrm>
+              <a:off x="5728668" y="2263428"/>
+              <a:ext cx="498406" cy="369332"/>
+            </a:xfrm>
+            <a:prstGeom prst="rect">
+              <a:avLst/>
+            </a:prstGeom>
+            <a:noFill/>
+          </p:spPr>
+          <p:txBody>
+            <a:bodyPr wrap="none" rtlCol="0">
+              <a:spAutoFit/>
+            </a:bodyPr>
+            <a:lstStyle/>
+            <a:p>
+              <a:r>
+                <a:rPr lang="en-US" dirty="0">
+                  <a:solidFill>
+                    <a:srgbClr val="FF0000"/>
+                  </a:solidFill>
+                </a:rPr>
+                <a:t>left</a:t>
+              </a:r>
+            </a:p>
+          </p:txBody>
+        </p:sp>
+        <p:sp>
+          <p:nvSpPr>
+            <p:cNvPr id="67" name="TextBox 66">
+              <a:extLst>
+                <a:ext uri="{FF2B5EF4-FFF2-40B4-BE49-F238E27FC236}">
+                  <a16:creationId xmlns:a16="http://schemas.microsoft.com/office/drawing/2014/main" id="{45E93BD0-403E-7C44-ACC4-B00592A9B16E}"/>
+                </a:ext>
+              </a:extLst>
+            </p:cNvPr>
+            <p:cNvSpPr txBox="1"/>
+            <p:nvPr/>
+          </p:nvSpPr>
+          <p:spPr>
+            <a:xfrm>
+              <a:off x="6308319" y="2952009"/>
+              <a:ext cx="623376" cy="369332"/>
+            </a:xfrm>
+            <a:prstGeom prst="rect">
+              <a:avLst/>
+            </a:prstGeom>
+            <a:noFill/>
+          </p:spPr>
+          <p:txBody>
+            <a:bodyPr wrap="none" rtlCol="0">
+              <a:spAutoFit/>
+            </a:bodyPr>
+            <a:lstStyle/>
+            <a:p>
+              <a:r>
+                <a:rPr lang="en-US" dirty="0"/>
+                <a:t>right</a:t>
+              </a:r>
+            </a:p>
+          </p:txBody>
+        </p:sp>
+      </p:grpSp>
     </p:spTree>
     <p:extLst>
       <p:ext uri="{BB962C8B-B14F-4D97-AF65-F5344CB8AC3E}">

</xml_diff>

<commit_message>
Towards using ruler to mark mouse state.
</commit_message>
<xml_diff>
--- a/limb_position.pptx
+++ b/limb_position.pptx
@@ -6,6 +6,9 @@
   </p:sldMasterIdLst>
   <p:sldIdLst>
     <p:sldId id="262" r:id="rId2"/>
+    <p:sldId id="264" r:id="rId3"/>
+    <p:sldId id="265" r:id="rId4"/>
+    <p:sldId id="256" r:id="rId5"/>
   </p:sldIdLst>
   <p:sldSz cx="12192000" cy="6858000"/>
   <p:notesSz cx="6858000" cy="9144000"/>
@@ -259,7 +262,7 @@
           <a:p>
             <a:fld id="{05BB03CD-114E-7A44-9A61-E9E2400EDBDE}" type="datetimeFigureOut">
               <a:rPr lang="en-US" smtClean="0"/>
-              <a:t>2/15/24</a:t>
+              <a:t>2/19/24</a:t>
             </a:fld>
             <a:endParaRPr lang="en-US"/>
           </a:p>
@@ -457,7 +460,7 @@
           <a:p>
             <a:fld id="{05BB03CD-114E-7A44-9A61-E9E2400EDBDE}" type="datetimeFigureOut">
               <a:rPr lang="en-US" smtClean="0"/>
-              <a:t>2/15/24</a:t>
+              <a:t>2/19/24</a:t>
             </a:fld>
             <a:endParaRPr lang="en-US"/>
           </a:p>
@@ -665,7 +668,7 @@
           <a:p>
             <a:fld id="{05BB03CD-114E-7A44-9A61-E9E2400EDBDE}" type="datetimeFigureOut">
               <a:rPr lang="en-US" smtClean="0"/>
-              <a:t>2/15/24</a:t>
+              <a:t>2/19/24</a:t>
             </a:fld>
             <a:endParaRPr lang="en-US"/>
           </a:p>
@@ -863,7 +866,7 @@
           <a:p>
             <a:fld id="{05BB03CD-114E-7A44-9A61-E9E2400EDBDE}" type="datetimeFigureOut">
               <a:rPr lang="en-US" smtClean="0"/>
-              <a:t>2/15/24</a:t>
+              <a:t>2/19/24</a:t>
             </a:fld>
             <a:endParaRPr lang="en-US"/>
           </a:p>
@@ -1138,7 +1141,7 @@
           <a:p>
             <a:fld id="{05BB03CD-114E-7A44-9A61-E9E2400EDBDE}" type="datetimeFigureOut">
               <a:rPr lang="en-US" smtClean="0"/>
-              <a:t>2/15/24</a:t>
+              <a:t>2/19/24</a:t>
             </a:fld>
             <a:endParaRPr lang="en-US"/>
           </a:p>
@@ -1403,7 +1406,7 @@
           <a:p>
             <a:fld id="{05BB03CD-114E-7A44-9A61-E9E2400EDBDE}" type="datetimeFigureOut">
               <a:rPr lang="en-US" smtClean="0"/>
-              <a:t>2/15/24</a:t>
+              <a:t>2/19/24</a:t>
             </a:fld>
             <a:endParaRPr lang="en-US"/>
           </a:p>
@@ -1815,7 +1818,7 @@
           <a:p>
             <a:fld id="{05BB03CD-114E-7A44-9A61-E9E2400EDBDE}" type="datetimeFigureOut">
               <a:rPr lang="en-US" smtClean="0"/>
-              <a:t>2/15/24</a:t>
+              <a:t>2/19/24</a:t>
             </a:fld>
             <a:endParaRPr lang="en-US"/>
           </a:p>
@@ -1956,7 +1959,7 @@
           <a:p>
             <a:fld id="{05BB03CD-114E-7A44-9A61-E9E2400EDBDE}" type="datetimeFigureOut">
               <a:rPr lang="en-US" smtClean="0"/>
-              <a:t>2/15/24</a:t>
+              <a:t>2/19/24</a:t>
             </a:fld>
             <a:endParaRPr lang="en-US"/>
           </a:p>
@@ -2069,7 +2072,7 @@
           <a:p>
             <a:fld id="{05BB03CD-114E-7A44-9A61-E9E2400EDBDE}" type="datetimeFigureOut">
               <a:rPr lang="en-US" smtClean="0"/>
-              <a:t>2/15/24</a:t>
+              <a:t>2/19/24</a:t>
             </a:fld>
             <a:endParaRPr lang="en-US"/>
           </a:p>
@@ -2380,7 +2383,7 @@
           <a:p>
             <a:fld id="{05BB03CD-114E-7A44-9A61-E9E2400EDBDE}" type="datetimeFigureOut">
               <a:rPr lang="en-US" smtClean="0"/>
-              <a:t>2/15/24</a:t>
+              <a:t>2/19/24</a:t>
             </a:fld>
             <a:endParaRPr lang="en-US"/>
           </a:p>
@@ -2668,7 +2671,7 @@
           <a:p>
             <a:fld id="{05BB03CD-114E-7A44-9A61-E9E2400EDBDE}" type="datetimeFigureOut">
               <a:rPr lang="en-US" smtClean="0"/>
-              <a:t>2/15/24</a:t>
+              <a:t>2/19/24</a:t>
             </a:fld>
             <a:endParaRPr lang="en-US"/>
           </a:p>
@@ -2909,7 +2912,7 @@
           <a:p>
             <a:fld id="{05BB03CD-114E-7A44-9A61-E9E2400EDBDE}" type="datetimeFigureOut">
               <a:rPr lang="en-US" smtClean="0"/>
-              <a:t>2/15/24</a:t>
+              <a:t>2/19/24</a:t>
             </a:fld>
             <a:endParaRPr lang="en-US"/>
           </a:p>
@@ -3326,206 +3329,2229 @@
           <a:chExt cx="0" cy="0"/>
         </a:xfrm>
       </p:grpSpPr>
-      <p:sp>
-        <p:nvSpPr>
-          <p:cNvPr id="5" name="Rectangle 4">
-            <a:extLst>
-              <a:ext uri="{FF2B5EF4-FFF2-40B4-BE49-F238E27FC236}">
-                <a16:creationId xmlns:a16="http://schemas.microsoft.com/office/drawing/2014/main" id="{3F76A8F3-41A0-264E-9D30-16614BE725B1}"/>
-              </a:ext>
-            </a:extLst>
-          </p:cNvPr>
-          <p:cNvSpPr/>
+      <p:grpSp>
+        <p:nvGrpSpPr>
+          <p:cNvPr id="57" name="Group 56">
+            <a:extLst>
+              <a:ext uri="{FF2B5EF4-FFF2-40B4-BE49-F238E27FC236}">
+                <a16:creationId xmlns:a16="http://schemas.microsoft.com/office/drawing/2014/main" id="{1DF87100-9A29-0E45-A2C1-4EF79521D4AF}"/>
+              </a:ext>
+            </a:extLst>
+          </p:cNvPr>
+          <p:cNvGrpSpPr/>
           <p:nvPr/>
-        </p:nvSpPr>
-        <p:spPr>
+        </p:nvGrpSpPr>
+        <p:grpSpPr>
           <a:xfrm>
-            <a:off x="4846623" y="2007006"/>
-            <a:ext cx="102386" cy="383943"/>
+            <a:off x="4145487" y="1989055"/>
+            <a:ext cx="1415940" cy="1300909"/>
+            <a:chOff x="4145487" y="1989055"/>
+            <a:chExt cx="1415940" cy="1300909"/>
           </a:xfrm>
-          <a:prstGeom prst="rect">
-            <a:avLst/>
-          </a:prstGeom>
-        </p:spPr>
-        <p:style>
-          <a:lnRef idx="2">
-            <a:schemeClr val="accent3">
-              <a:shade val="50000"/>
-            </a:schemeClr>
-          </a:lnRef>
-          <a:fillRef idx="1">
-            <a:schemeClr val="accent3"/>
-          </a:fillRef>
-          <a:effectRef idx="0">
-            <a:schemeClr val="accent3"/>
-          </a:effectRef>
-          <a:fontRef idx="minor">
-            <a:schemeClr val="lt1"/>
-          </a:fontRef>
-        </p:style>
-        <p:txBody>
-          <a:bodyPr rtlCol="0" anchor="ctr"/>
-          <a:lstStyle/>
-          <a:p>
-            <a:pPr algn="ctr"/>
-            <a:endParaRPr lang="en-US"/>
-          </a:p>
-        </p:txBody>
-      </p:sp>
-      <p:sp>
-        <p:nvSpPr>
-          <p:cNvPr id="2" name="Oval 1">
-            <a:extLst>
-              <a:ext uri="{FF2B5EF4-FFF2-40B4-BE49-F238E27FC236}">
-                <a16:creationId xmlns:a16="http://schemas.microsoft.com/office/drawing/2014/main" id="{41823AD5-E3D5-6A44-BFAF-506BFE319FAC}"/>
-              </a:ext>
-            </a:extLst>
-          </p:cNvPr>
-          <p:cNvSpPr/>
+        </p:grpSpPr>
+        <p:grpSp>
+          <p:nvGrpSpPr>
+            <p:cNvPr id="26" name="Group 25">
+              <a:extLst>
+                <a:ext uri="{FF2B5EF4-FFF2-40B4-BE49-F238E27FC236}">
+                  <a16:creationId xmlns:a16="http://schemas.microsoft.com/office/drawing/2014/main" id="{7E5DA20A-B142-5B42-88E6-FA5D801AA313}"/>
+                </a:ext>
+              </a:extLst>
+            </p:cNvPr>
+            <p:cNvGrpSpPr/>
+            <p:nvPr/>
+          </p:nvGrpSpPr>
+          <p:grpSpPr>
+            <a:xfrm>
+              <a:off x="4145487" y="1989055"/>
+              <a:ext cx="1208801" cy="1300909"/>
+              <a:chOff x="4145487" y="1989055"/>
+              <a:chExt cx="1208801" cy="1300909"/>
+            </a:xfrm>
+          </p:grpSpPr>
+          <p:sp>
+            <p:nvSpPr>
+              <p:cNvPr id="5" name="Rectangle 4">
+                <a:extLst>
+                  <a:ext uri="{FF2B5EF4-FFF2-40B4-BE49-F238E27FC236}">
+                    <a16:creationId xmlns:a16="http://schemas.microsoft.com/office/drawing/2014/main" id="{3F76A8F3-41A0-264E-9D30-16614BE725B1}"/>
+                  </a:ext>
+                </a:extLst>
+              </p:cNvPr>
+              <p:cNvSpPr/>
+              <p:nvPr/>
+            </p:nvSpPr>
+            <p:spPr>
+              <a:xfrm>
+                <a:off x="4846623" y="2007006"/>
+                <a:ext cx="102386" cy="383943"/>
+              </a:xfrm>
+              <a:prstGeom prst="rect">
+                <a:avLst/>
+              </a:prstGeom>
+            </p:spPr>
+            <p:style>
+              <a:lnRef idx="2">
+                <a:schemeClr val="accent3">
+                  <a:shade val="50000"/>
+                </a:schemeClr>
+              </a:lnRef>
+              <a:fillRef idx="1">
+                <a:schemeClr val="accent3"/>
+              </a:fillRef>
+              <a:effectRef idx="0">
+                <a:schemeClr val="accent3"/>
+              </a:effectRef>
+              <a:fontRef idx="minor">
+                <a:schemeClr val="lt1"/>
+              </a:fontRef>
+            </p:style>
+            <p:txBody>
+              <a:bodyPr rtlCol="0" anchor="ctr"/>
+              <a:lstStyle/>
+              <a:p>
+                <a:pPr algn="ctr"/>
+                <a:endParaRPr lang="en-US"/>
+              </a:p>
+            </p:txBody>
+          </p:sp>
+          <p:sp>
+            <p:nvSpPr>
+              <p:cNvPr id="2" name="Oval 1">
+                <a:extLst>
+                  <a:ext uri="{FF2B5EF4-FFF2-40B4-BE49-F238E27FC236}">
+                    <a16:creationId xmlns:a16="http://schemas.microsoft.com/office/drawing/2014/main" id="{41823AD5-E3D5-6A44-BFAF-506BFE319FAC}"/>
+                  </a:ext>
+                </a:extLst>
+              </p:cNvPr>
+              <p:cNvSpPr/>
+              <p:nvPr/>
+            </p:nvSpPr>
+            <p:spPr>
+              <a:xfrm>
+                <a:off x="4421894" y="2238546"/>
+                <a:ext cx="932394" cy="932394"/>
+              </a:xfrm>
+              <a:prstGeom prst="ellipse">
+                <a:avLst/>
+              </a:prstGeom>
+            </p:spPr>
+            <p:style>
+              <a:lnRef idx="2">
+                <a:schemeClr val="accent3">
+                  <a:shade val="50000"/>
+                </a:schemeClr>
+              </a:lnRef>
+              <a:fillRef idx="1">
+                <a:schemeClr val="accent3"/>
+              </a:fillRef>
+              <a:effectRef idx="0">
+                <a:schemeClr val="accent3"/>
+              </a:effectRef>
+              <a:fontRef idx="minor">
+                <a:schemeClr val="lt1"/>
+              </a:fontRef>
+            </p:style>
+            <p:txBody>
+              <a:bodyPr rot="0" spcFirstLastPara="0" vertOverflow="overflow" horzOverflow="overflow" vert="horz" wrap="square" lIns="91440" tIns="45720" rIns="91440" bIns="45720" numCol="1" spcCol="0" rtlCol="0" fromWordArt="0" anchor="ctr" anchorCtr="0" forceAA="0" compatLnSpc="1">
+                <a:prstTxWarp prst="textNoShape">
+                  <a:avLst/>
+                </a:prstTxWarp>
+                <a:noAutofit/>
+              </a:bodyPr>
+              <a:lstStyle/>
+              <a:p>
+                <a:pPr algn="ctr"/>
+                <a:endParaRPr lang="en-US" dirty="0"/>
+              </a:p>
+            </p:txBody>
+          </p:sp>
+          <p:sp>
+            <p:nvSpPr>
+              <p:cNvPr id="56" name="Can 55">
+                <a:extLst>
+                  <a:ext uri="{FF2B5EF4-FFF2-40B4-BE49-F238E27FC236}">
+                    <a16:creationId xmlns:a16="http://schemas.microsoft.com/office/drawing/2014/main" id="{AAC1A6EF-A8F8-F44A-A4DF-6CB5A4ABD55D}"/>
+                  </a:ext>
+                </a:extLst>
+              </p:cNvPr>
+              <p:cNvSpPr/>
+              <p:nvPr/>
+            </p:nvSpPr>
+            <p:spPr>
+              <a:xfrm rot="13544981">
+                <a:off x="4443044" y="2520030"/>
+                <a:ext cx="222192" cy="743133"/>
+              </a:xfrm>
+              <a:prstGeom prst="can">
+                <a:avLst/>
+              </a:prstGeom>
+              <a:solidFill>
+                <a:schemeClr val="bg1">
+                  <a:lumMod val="75000"/>
+                </a:schemeClr>
+              </a:solidFill>
+              <a:ln>
+                <a:solidFill>
+                  <a:schemeClr val="bg1">
+                    <a:lumMod val="50000"/>
+                  </a:schemeClr>
+                </a:solidFill>
+              </a:ln>
+            </p:spPr>
+            <p:style>
+              <a:lnRef idx="2">
+                <a:schemeClr val="accent1">
+                  <a:shade val="50000"/>
+                </a:schemeClr>
+              </a:lnRef>
+              <a:fillRef idx="1">
+                <a:schemeClr val="accent1"/>
+              </a:fillRef>
+              <a:effectRef idx="0">
+                <a:schemeClr val="accent1"/>
+              </a:effectRef>
+              <a:fontRef idx="minor">
+                <a:schemeClr val="lt1"/>
+              </a:fontRef>
+            </p:style>
+            <p:txBody>
+              <a:bodyPr rtlCol="0" anchor="ctr"/>
+              <a:lstStyle/>
+              <a:p>
+                <a:pPr algn="ctr"/>
+                <a:endParaRPr lang="en-US" dirty="0"/>
+              </a:p>
+            </p:txBody>
+          </p:sp>
+          <p:sp>
+            <p:nvSpPr>
+              <p:cNvPr id="4" name="Oval 3">
+                <a:extLst>
+                  <a:ext uri="{FF2B5EF4-FFF2-40B4-BE49-F238E27FC236}">
+                    <a16:creationId xmlns:a16="http://schemas.microsoft.com/office/drawing/2014/main" id="{FEB4EB90-88F1-3244-A9F9-A2E192B91AAA}"/>
+                  </a:ext>
+                </a:extLst>
+              </p:cNvPr>
+              <p:cNvSpPr/>
+              <p:nvPr/>
+            </p:nvSpPr>
+            <p:spPr>
+              <a:xfrm>
+                <a:off x="4846623" y="2419127"/>
+                <a:ext cx="102386" cy="277597"/>
+              </a:xfrm>
+              <a:prstGeom prst="ellipse">
+                <a:avLst/>
+              </a:prstGeom>
+              <a:solidFill>
+                <a:schemeClr val="bg1">
+                  <a:lumMod val="75000"/>
+                </a:schemeClr>
+              </a:solidFill>
+              <a:ln>
+                <a:solidFill>
+                  <a:schemeClr val="bg1">
+                    <a:lumMod val="50000"/>
+                  </a:schemeClr>
+                </a:solidFill>
+              </a:ln>
+            </p:spPr>
+            <p:style>
+              <a:lnRef idx="2">
+                <a:schemeClr val="accent1">
+                  <a:shade val="50000"/>
+                </a:schemeClr>
+              </a:lnRef>
+              <a:fillRef idx="1">
+                <a:schemeClr val="accent1"/>
+              </a:fillRef>
+              <a:effectRef idx="0">
+                <a:schemeClr val="accent1"/>
+              </a:effectRef>
+              <a:fontRef idx="minor">
+                <a:schemeClr val="lt1"/>
+              </a:fontRef>
+            </p:style>
+            <p:txBody>
+              <a:bodyPr rtlCol="0" anchor="ctr"/>
+              <a:lstStyle/>
+              <a:p>
+                <a:pPr algn="ctr"/>
+                <a:endParaRPr lang="en-US"/>
+              </a:p>
+            </p:txBody>
+          </p:sp>
+          <p:sp>
+            <p:nvSpPr>
+              <p:cNvPr id="6" name="Oval 5">
+                <a:extLst>
+                  <a:ext uri="{FF2B5EF4-FFF2-40B4-BE49-F238E27FC236}">
+                    <a16:creationId xmlns:a16="http://schemas.microsoft.com/office/drawing/2014/main" id="{353558FB-3386-4845-8975-BCF8EA068A0F}"/>
+                  </a:ext>
+                </a:extLst>
+              </p:cNvPr>
+              <p:cNvSpPr/>
+              <p:nvPr/>
+            </p:nvSpPr>
+            <p:spPr>
+              <a:xfrm rot="20997034">
+                <a:off x="4160992" y="3006302"/>
+                <a:ext cx="343675" cy="207932"/>
+              </a:xfrm>
+              <a:prstGeom prst="ellipse">
+                <a:avLst/>
+              </a:prstGeom>
+              <a:solidFill>
+                <a:schemeClr val="bg1">
+                  <a:lumMod val="75000"/>
+                </a:schemeClr>
+              </a:solidFill>
+              <a:ln>
+                <a:solidFill>
+                  <a:schemeClr val="bg1">
+                    <a:lumMod val="50000"/>
+                  </a:schemeClr>
+                </a:solidFill>
+              </a:ln>
+            </p:spPr>
+            <p:style>
+              <a:lnRef idx="2">
+                <a:schemeClr val="accent1">
+                  <a:shade val="50000"/>
+                </a:schemeClr>
+              </a:lnRef>
+              <a:fillRef idx="1">
+                <a:schemeClr val="accent1"/>
+              </a:fillRef>
+              <a:effectRef idx="0">
+                <a:schemeClr val="accent1"/>
+              </a:effectRef>
+              <a:fontRef idx="minor">
+                <a:schemeClr val="lt1"/>
+              </a:fontRef>
+            </p:style>
+            <p:txBody>
+              <a:bodyPr rtlCol="0" anchor="ctr"/>
+              <a:lstStyle/>
+              <a:p>
+                <a:pPr algn="ctr"/>
+                <a:endParaRPr lang="en-US"/>
+              </a:p>
+            </p:txBody>
+          </p:sp>
+          <p:cxnSp>
+            <p:nvCxnSpPr>
+              <p:cNvPr id="40" name="Straight Connector 39">
+                <a:extLst>
+                  <a:ext uri="{FF2B5EF4-FFF2-40B4-BE49-F238E27FC236}">
+                    <a16:creationId xmlns:a16="http://schemas.microsoft.com/office/drawing/2014/main" id="{04132F47-0067-E44E-B010-6D2282F2E247}"/>
+                  </a:ext>
+                </a:extLst>
+              </p:cNvPr>
+              <p:cNvCxnSpPr>
+                <a:cxnSpLocks/>
+              </p:cNvCxnSpPr>
+              <p:nvPr/>
+            </p:nvCxnSpPr>
+            <p:spPr>
+              <a:xfrm flipH="1">
+                <a:off x="4175542" y="3109186"/>
+                <a:ext cx="41467" cy="37028"/>
+              </a:xfrm>
+              <a:prstGeom prst="line">
+                <a:avLst/>
+              </a:prstGeom>
+              <a:ln>
+                <a:solidFill>
+                  <a:schemeClr val="bg1"/>
+                </a:solidFill>
+              </a:ln>
+            </p:spPr>
+            <p:style>
+              <a:lnRef idx="1">
+                <a:schemeClr val="accent1"/>
+              </a:lnRef>
+              <a:fillRef idx="0">
+                <a:schemeClr val="accent1"/>
+              </a:fillRef>
+              <a:effectRef idx="0">
+                <a:schemeClr val="accent1"/>
+              </a:effectRef>
+              <a:fontRef idx="minor">
+                <a:schemeClr val="tx1"/>
+              </a:fontRef>
+            </p:style>
+          </p:cxnSp>
+          <p:cxnSp>
+            <p:nvCxnSpPr>
+              <p:cNvPr id="43" name="Straight Connector 42">
+                <a:extLst>
+                  <a:ext uri="{FF2B5EF4-FFF2-40B4-BE49-F238E27FC236}">
+                    <a16:creationId xmlns:a16="http://schemas.microsoft.com/office/drawing/2014/main" id="{13D448C0-129B-E248-AA7A-F160E1705FEC}"/>
+                  </a:ext>
+                </a:extLst>
+              </p:cNvPr>
+              <p:cNvCxnSpPr>
+                <a:cxnSpLocks/>
+              </p:cNvCxnSpPr>
+              <p:nvPr/>
+            </p:nvCxnSpPr>
+            <p:spPr>
+              <a:xfrm flipH="1">
+                <a:off x="4199450" y="3140696"/>
+                <a:ext cx="41467" cy="37028"/>
+              </a:xfrm>
+              <a:prstGeom prst="line">
+                <a:avLst/>
+              </a:prstGeom>
+              <a:ln>
+                <a:solidFill>
+                  <a:schemeClr val="bg1"/>
+                </a:solidFill>
+              </a:ln>
+            </p:spPr>
+            <p:style>
+              <a:lnRef idx="1">
+                <a:schemeClr val="accent1"/>
+              </a:lnRef>
+              <a:fillRef idx="0">
+                <a:schemeClr val="accent1"/>
+              </a:fillRef>
+              <a:effectRef idx="0">
+                <a:schemeClr val="accent1"/>
+              </a:effectRef>
+              <a:fontRef idx="minor">
+                <a:schemeClr val="tx1"/>
+              </a:fontRef>
+            </p:style>
+          </p:cxnSp>
+          <p:cxnSp>
+            <p:nvCxnSpPr>
+              <p:cNvPr id="48" name="Straight Connector 47">
+                <a:extLst>
+                  <a:ext uri="{FF2B5EF4-FFF2-40B4-BE49-F238E27FC236}">
+                    <a16:creationId xmlns:a16="http://schemas.microsoft.com/office/drawing/2014/main" id="{0059D9F6-FDAA-FB4E-9D50-0759BA98222B}"/>
+                  </a:ext>
+                </a:extLst>
+              </p:cNvPr>
+              <p:cNvCxnSpPr>
+                <a:cxnSpLocks/>
+              </p:cNvCxnSpPr>
+              <p:nvPr/>
+            </p:nvCxnSpPr>
+            <p:spPr>
+              <a:xfrm flipH="1">
+                <a:off x="4237936" y="3161257"/>
+                <a:ext cx="41467" cy="37028"/>
+              </a:xfrm>
+              <a:prstGeom prst="line">
+                <a:avLst/>
+              </a:prstGeom>
+              <a:ln>
+                <a:solidFill>
+                  <a:schemeClr val="bg1"/>
+                </a:solidFill>
+              </a:ln>
+            </p:spPr>
+            <p:style>
+              <a:lnRef idx="1">
+                <a:schemeClr val="accent1"/>
+              </a:lnRef>
+              <a:fillRef idx="0">
+                <a:schemeClr val="accent1"/>
+              </a:fillRef>
+              <a:effectRef idx="0">
+                <a:schemeClr val="accent1"/>
+              </a:effectRef>
+              <a:fontRef idx="minor">
+                <a:schemeClr val="tx1"/>
+              </a:fontRef>
+            </p:style>
+          </p:cxnSp>
+          <p:cxnSp>
+            <p:nvCxnSpPr>
+              <p:cNvPr id="51" name="Straight Connector 50">
+                <a:extLst>
+                  <a:ext uri="{FF2B5EF4-FFF2-40B4-BE49-F238E27FC236}">
+                    <a16:creationId xmlns:a16="http://schemas.microsoft.com/office/drawing/2014/main" id="{79605622-9A78-6B4C-94FC-0336315F3988}"/>
+                  </a:ext>
+                </a:extLst>
+              </p:cNvPr>
+              <p:cNvCxnSpPr>
+                <a:cxnSpLocks/>
+              </p:cNvCxnSpPr>
+              <p:nvPr/>
+            </p:nvCxnSpPr>
+            <p:spPr>
+              <a:xfrm flipH="1">
+                <a:off x="4290876" y="3173421"/>
+                <a:ext cx="41467" cy="37028"/>
+              </a:xfrm>
+              <a:prstGeom prst="line">
+                <a:avLst/>
+              </a:prstGeom>
+              <a:ln>
+                <a:solidFill>
+                  <a:schemeClr val="bg1"/>
+                </a:solidFill>
+              </a:ln>
+            </p:spPr>
+            <p:style>
+              <a:lnRef idx="1">
+                <a:schemeClr val="accent1"/>
+              </a:lnRef>
+              <a:fillRef idx="0">
+                <a:schemeClr val="accent1"/>
+              </a:fillRef>
+              <a:effectRef idx="0">
+                <a:schemeClr val="accent1"/>
+              </a:effectRef>
+              <a:fontRef idx="minor">
+                <a:schemeClr val="tx1"/>
+              </a:fontRef>
+            </p:style>
+          </p:cxnSp>
+          <p:sp>
+            <p:nvSpPr>
+              <p:cNvPr id="47" name="Rectangle 46">
+                <a:extLst>
+                  <a:ext uri="{FF2B5EF4-FFF2-40B4-BE49-F238E27FC236}">
+                    <a16:creationId xmlns:a16="http://schemas.microsoft.com/office/drawing/2014/main" id="{73B63520-6DBB-3F4A-A04F-989995A5459E}"/>
+                  </a:ext>
+                </a:extLst>
+              </p:cNvPr>
+              <p:cNvSpPr/>
+              <p:nvPr/>
+            </p:nvSpPr>
+            <p:spPr>
+              <a:xfrm>
+                <a:off x="4145487" y="1989055"/>
+                <a:ext cx="843856" cy="1300909"/>
+              </a:xfrm>
+              <a:prstGeom prst="rect">
+                <a:avLst/>
+              </a:prstGeom>
+              <a:noFill/>
+              <a:ln>
+                <a:solidFill>
+                  <a:schemeClr val="bg1">
+                    <a:lumMod val="85000"/>
+                  </a:schemeClr>
+                </a:solidFill>
+              </a:ln>
+            </p:spPr>
+            <p:style>
+              <a:lnRef idx="2">
+                <a:schemeClr val="accent1">
+                  <a:shade val="50000"/>
+                </a:schemeClr>
+              </a:lnRef>
+              <a:fillRef idx="1">
+                <a:schemeClr val="accent1"/>
+              </a:fillRef>
+              <a:effectRef idx="0">
+                <a:schemeClr val="accent1"/>
+              </a:effectRef>
+              <a:fontRef idx="minor">
+                <a:schemeClr val="lt1"/>
+              </a:fontRef>
+            </p:style>
+            <p:txBody>
+              <a:bodyPr rtlCol="0" anchor="ctr"/>
+              <a:lstStyle/>
+              <a:p>
+                <a:pPr algn="ctr"/>
+                <a:endParaRPr lang="en-US"/>
+              </a:p>
+            </p:txBody>
+          </p:sp>
+        </p:grpSp>
+        <p:sp>
+          <p:nvSpPr>
+            <p:cNvPr id="27" name="Rectangle 26">
+              <a:extLst>
+                <a:ext uri="{FF2B5EF4-FFF2-40B4-BE49-F238E27FC236}">
+                  <a16:creationId xmlns:a16="http://schemas.microsoft.com/office/drawing/2014/main" id="{6F150C28-A1D3-BF49-A6DC-A2507906D1B0}"/>
+                </a:ext>
+              </a:extLst>
+            </p:cNvPr>
+            <p:cNvSpPr/>
+            <p:nvPr/>
+          </p:nvSpPr>
+          <p:spPr>
+            <a:xfrm>
+              <a:off x="5003409" y="1989055"/>
+              <a:ext cx="558018" cy="1300909"/>
+            </a:xfrm>
+            <a:prstGeom prst="rect">
+              <a:avLst/>
+            </a:prstGeom>
+            <a:solidFill>
+              <a:schemeClr val="bg1"/>
+            </a:solidFill>
+            <a:ln>
+              <a:solidFill>
+                <a:schemeClr val="bg1"/>
+              </a:solidFill>
+            </a:ln>
+          </p:spPr>
+          <p:style>
+            <a:lnRef idx="2">
+              <a:schemeClr val="accent1">
+                <a:shade val="50000"/>
+              </a:schemeClr>
+            </a:lnRef>
+            <a:fillRef idx="1">
+              <a:schemeClr val="accent1"/>
+            </a:fillRef>
+            <a:effectRef idx="0">
+              <a:schemeClr val="accent1"/>
+            </a:effectRef>
+            <a:fontRef idx="minor">
+              <a:schemeClr val="lt1"/>
+            </a:fontRef>
+          </p:style>
+          <p:txBody>
+            <a:bodyPr rtlCol="0" anchor="ctr"/>
+            <a:lstStyle/>
+            <a:p>
+              <a:pPr algn="ctr"/>
+              <a:endParaRPr lang="en-US"/>
+            </a:p>
+          </p:txBody>
+        </p:sp>
+        <p:cxnSp>
+          <p:nvCxnSpPr>
+            <p:cNvPr id="29" name="Straight Connector 28">
+              <a:extLst>
+                <a:ext uri="{FF2B5EF4-FFF2-40B4-BE49-F238E27FC236}">
+                  <a16:creationId xmlns:a16="http://schemas.microsoft.com/office/drawing/2014/main" id="{F7F7F569-7214-BC4F-A46D-8DF00B93234B}"/>
+                </a:ext>
+              </a:extLst>
+            </p:cNvPr>
+            <p:cNvCxnSpPr>
+              <a:cxnSpLocks/>
+            </p:cNvCxnSpPr>
+            <p:nvPr/>
+          </p:nvCxnSpPr>
+          <p:spPr>
+            <a:xfrm flipV="1">
+              <a:off x="4330406" y="2568425"/>
+              <a:ext cx="578424" cy="553469"/>
+            </a:xfrm>
+            <a:prstGeom prst="line">
+              <a:avLst/>
+            </a:prstGeom>
+            <a:ln w="38100">
+              <a:solidFill>
+                <a:srgbClr val="00B050"/>
+              </a:solidFill>
+            </a:ln>
+          </p:spPr>
+          <p:style>
+            <a:lnRef idx="1">
+              <a:schemeClr val="accent1"/>
+            </a:lnRef>
+            <a:fillRef idx="0">
+              <a:schemeClr val="accent1"/>
+            </a:fillRef>
+            <a:effectRef idx="0">
+              <a:schemeClr val="accent1"/>
+            </a:effectRef>
+            <a:fontRef idx="minor">
+              <a:schemeClr val="tx1"/>
+            </a:fontRef>
+          </p:style>
+        </p:cxnSp>
+      </p:grpSp>
+    </p:spTree>
+    <p:extLst>
+      <p:ext uri="{BB962C8B-B14F-4D97-AF65-F5344CB8AC3E}">
+        <p14:creationId xmlns:p14="http://schemas.microsoft.com/office/powerpoint/2010/main" val="3225664317"/>
+      </p:ext>
+    </p:extLst>
+  </p:cSld>
+  <p:clrMapOvr>
+    <a:masterClrMapping/>
+  </p:clrMapOvr>
+</p:sld>
+</file>
+
+<file path=ppt/slides/slide2.xml><?xml version="1.0" encoding="utf-8"?>
+<p:sld xmlns:a="http://schemas.openxmlformats.org/drawingml/2006/main" xmlns:r="http://schemas.openxmlformats.org/officeDocument/2006/relationships" xmlns:p="http://schemas.openxmlformats.org/presentationml/2006/main">
+  <p:cSld>
+    <p:spTree>
+      <p:nvGrpSpPr>
+        <p:cNvPr id="1" name=""/>
+        <p:cNvGrpSpPr/>
+        <p:nvPr/>
+      </p:nvGrpSpPr>
+      <p:grpSpPr>
+        <a:xfrm>
+          <a:off x="0" y="0"/>
+          <a:ext cx="0" cy="0"/>
+          <a:chOff x="0" y="0"/>
+          <a:chExt cx="0" cy="0"/>
+        </a:xfrm>
+      </p:grpSpPr>
+      <p:grpSp>
+        <p:nvGrpSpPr>
+          <p:cNvPr id="57" name="Group 56">
+            <a:extLst>
+              <a:ext uri="{FF2B5EF4-FFF2-40B4-BE49-F238E27FC236}">
+                <a16:creationId xmlns:a16="http://schemas.microsoft.com/office/drawing/2014/main" id="{1DF87100-9A29-0E45-A2C1-4EF79521D4AF}"/>
+              </a:ext>
+            </a:extLst>
+          </p:cNvPr>
+          <p:cNvGrpSpPr/>
           <p:nvPr/>
-        </p:nvSpPr>
-        <p:spPr>
+        </p:nvGrpSpPr>
+        <p:grpSpPr>
+          <a:xfrm flipH="1">
+            <a:off x="4145487" y="1989055"/>
+            <a:ext cx="1415940" cy="1300909"/>
+            <a:chOff x="4145487" y="1989055"/>
+            <a:chExt cx="1415940" cy="1300909"/>
+          </a:xfrm>
+        </p:grpSpPr>
+        <p:grpSp>
+          <p:nvGrpSpPr>
+            <p:cNvPr id="26" name="Group 25">
+              <a:extLst>
+                <a:ext uri="{FF2B5EF4-FFF2-40B4-BE49-F238E27FC236}">
+                  <a16:creationId xmlns:a16="http://schemas.microsoft.com/office/drawing/2014/main" id="{7E5DA20A-B142-5B42-88E6-FA5D801AA313}"/>
+                </a:ext>
+              </a:extLst>
+            </p:cNvPr>
+            <p:cNvGrpSpPr/>
+            <p:nvPr/>
+          </p:nvGrpSpPr>
+          <p:grpSpPr>
+            <a:xfrm>
+              <a:off x="4145487" y="1989055"/>
+              <a:ext cx="1208801" cy="1300909"/>
+              <a:chOff x="4145487" y="1989055"/>
+              <a:chExt cx="1208801" cy="1300909"/>
+            </a:xfrm>
+          </p:grpSpPr>
+          <p:sp>
+            <p:nvSpPr>
+              <p:cNvPr id="5" name="Rectangle 4">
+                <a:extLst>
+                  <a:ext uri="{FF2B5EF4-FFF2-40B4-BE49-F238E27FC236}">
+                    <a16:creationId xmlns:a16="http://schemas.microsoft.com/office/drawing/2014/main" id="{3F76A8F3-41A0-264E-9D30-16614BE725B1}"/>
+                  </a:ext>
+                </a:extLst>
+              </p:cNvPr>
+              <p:cNvSpPr/>
+              <p:nvPr/>
+            </p:nvSpPr>
+            <p:spPr>
+              <a:xfrm>
+                <a:off x="4846623" y="2007006"/>
+                <a:ext cx="102386" cy="383943"/>
+              </a:xfrm>
+              <a:prstGeom prst="rect">
+                <a:avLst/>
+              </a:prstGeom>
+            </p:spPr>
+            <p:style>
+              <a:lnRef idx="2">
+                <a:schemeClr val="accent3">
+                  <a:shade val="50000"/>
+                </a:schemeClr>
+              </a:lnRef>
+              <a:fillRef idx="1">
+                <a:schemeClr val="accent3"/>
+              </a:fillRef>
+              <a:effectRef idx="0">
+                <a:schemeClr val="accent3"/>
+              </a:effectRef>
+              <a:fontRef idx="minor">
+                <a:schemeClr val="lt1"/>
+              </a:fontRef>
+            </p:style>
+            <p:txBody>
+              <a:bodyPr rtlCol="0" anchor="ctr"/>
+              <a:lstStyle/>
+              <a:p>
+                <a:pPr algn="ctr"/>
+                <a:endParaRPr lang="en-US"/>
+              </a:p>
+            </p:txBody>
+          </p:sp>
+          <p:sp>
+            <p:nvSpPr>
+              <p:cNvPr id="2" name="Oval 1">
+                <a:extLst>
+                  <a:ext uri="{FF2B5EF4-FFF2-40B4-BE49-F238E27FC236}">
+                    <a16:creationId xmlns:a16="http://schemas.microsoft.com/office/drawing/2014/main" id="{41823AD5-E3D5-6A44-BFAF-506BFE319FAC}"/>
+                  </a:ext>
+                </a:extLst>
+              </p:cNvPr>
+              <p:cNvSpPr/>
+              <p:nvPr/>
+            </p:nvSpPr>
+            <p:spPr>
+              <a:xfrm>
+                <a:off x="4421894" y="2238546"/>
+                <a:ext cx="932394" cy="932394"/>
+              </a:xfrm>
+              <a:prstGeom prst="ellipse">
+                <a:avLst/>
+              </a:prstGeom>
+            </p:spPr>
+            <p:style>
+              <a:lnRef idx="2">
+                <a:schemeClr val="accent3">
+                  <a:shade val="50000"/>
+                </a:schemeClr>
+              </a:lnRef>
+              <a:fillRef idx="1">
+                <a:schemeClr val="accent3"/>
+              </a:fillRef>
+              <a:effectRef idx="0">
+                <a:schemeClr val="accent3"/>
+              </a:effectRef>
+              <a:fontRef idx="minor">
+                <a:schemeClr val="lt1"/>
+              </a:fontRef>
+            </p:style>
+            <p:txBody>
+              <a:bodyPr rot="0" spcFirstLastPara="0" vertOverflow="overflow" horzOverflow="overflow" vert="horz" wrap="square" lIns="91440" tIns="45720" rIns="91440" bIns="45720" numCol="1" spcCol="0" rtlCol="0" fromWordArt="0" anchor="ctr" anchorCtr="0" forceAA="0" compatLnSpc="1">
+                <a:prstTxWarp prst="textNoShape">
+                  <a:avLst/>
+                </a:prstTxWarp>
+                <a:noAutofit/>
+              </a:bodyPr>
+              <a:lstStyle/>
+              <a:p>
+                <a:pPr algn="ctr"/>
+                <a:endParaRPr lang="en-US" dirty="0"/>
+              </a:p>
+            </p:txBody>
+          </p:sp>
+          <p:sp>
+            <p:nvSpPr>
+              <p:cNvPr id="56" name="Can 55">
+                <a:extLst>
+                  <a:ext uri="{FF2B5EF4-FFF2-40B4-BE49-F238E27FC236}">
+                    <a16:creationId xmlns:a16="http://schemas.microsoft.com/office/drawing/2014/main" id="{AAC1A6EF-A8F8-F44A-A4DF-6CB5A4ABD55D}"/>
+                  </a:ext>
+                </a:extLst>
+              </p:cNvPr>
+              <p:cNvSpPr/>
+              <p:nvPr/>
+            </p:nvSpPr>
+            <p:spPr>
+              <a:xfrm rot="13544981">
+                <a:off x="4443044" y="2520030"/>
+                <a:ext cx="222192" cy="743133"/>
+              </a:xfrm>
+              <a:prstGeom prst="can">
+                <a:avLst/>
+              </a:prstGeom>
+              <a:solidFill>
+                <a:schemeClr val="bg1">
+                  <a:lumMod val="75000"/>
+                </a:schemeClr>
+              </a:solidFill>
+              <a:ln>
+                <a:solidFill>
+                  <a:schemeClr val="bg1">
+                    <a:lumMod val="50000"/>
+                  </a:schemeClr>
+                </a:solidFill>
+              </a:ln>
+            </p:spPr>
+            <p:style>
+              <a:lnRef idx="2">
+                <a:schemeClr val="accent1">
+                  <a:shade val="50000"/>
+                </a:schemeClr>
+              </a:lnRef>
+              <a:fillRef idx="1">
+                <a:schemeClr val="accent1"/>
+              </a:fillRef>
+              <a:effectRef idx="0">
+                <a:schemeClr val="accent1"/>
+              </a:effectRef>
+              <a:fontRef idx="minor">
+                <a:schemeClr val="lt1"/>
+              </a:fontRef>
+            </p:style>
+            <p:txBody>
+              <a:bodyPr rtlCol="0" anchor="ctr"/>
+              <a:lstStyle/>
+              <a:p>
+                <a:pPr algn="ctr"/>
+                <a:endParaRPr lang="en-US" dirty="0"/>
+              </a:p>
+            </p:txBody>
+          </p:sp>
+          <p:sp>
+            <p:nvSpPr>
+              <p:cNvPr id="4" name="Oval 3">
+                <a:extLst>
+                  <a:ext uri="{FF2B5EF4-FFF2-40B4-BE49-F238E27FC236}">
+                    <a16:creationId xmlns:a16="http://schemas.microsoft.com/office/drawing/2014/main" id="{FEB4EB90-88F1-3244-A9F9-A2E192B91AAA}"/>
+                  </a:ext>
+                </a:extLst>
+              </p:cNvPr>
+              <p:cNvSpPr/>
+              <p:nvPr/>
+            </p:nvSpPr>
+            <p:spPr>
+              <a:xfrm>
+                <a:off x="4846623" y="2419127"/>
+                <a:ext cx="102386" cy="277597"/>
+              </a:xfrm>
+              <a:prstGeom prst="ellipse">
+                <a:avLst/>
+              </a:prstGeom>
+              <a:solidFill>
+                <a:schemeClr val="bg1">
+                  <a:lumMod val="75000"/>
+                </a:schemeClr>
+              </a:solidFill>
+              <a:ln>
+                <a:solidFill>
+                  <a:schemeClr val="bg1">
+                    <a:lumMod val="50000"/>
+                  </a:schemeClr>
+                </a:solidFill>
+              </a:ln>
+            </p:spPr>
+            <p:style>
+              <a:lnRef idx="2">
+                <a:schemeClr val="accent1">
+                  <a:shade val="50000"/>
+                </a:schemeClr>
+              </a:lnRef>
+              <a:fillRef idx="1">
+                <a:schemeClr val="accent1"/>
+              </a:fillRef>
+              <a:effectRef idx="0">
+                <a:schemeClr val="accent1"/>
+              </a:effectRef>
+              <a:fontRef idx="minor">
+                <a:schemeClr val="lt1"/>
+              </a:fontRef>
+            </p:style>
+            <p:txBody>
+              <a:bodyPr rtlCol="0" anchor="ctr"/>
+              <a:lstStyle/>
+              <a:p>
+                <a:pPr algn="ctr"/>
+                <a:endParaRPr lang="en-US"/>
+              </a:p>
+            </p:txBody>
+          </p:sp>
+          <p:sp>
+            <p:nvSpPr>
+              <p:cNvPr id="6" name="Oval 5">
+                <a:extLst>
+                  <a:ext uri="{FF2B5EF4-FFF2-40B4-BE49-F238E27FC236}">
+                    <a16:creationId xmlns:a16="http://schemas.microsoft.com/office/drawing/2014/main" id="{353558FB-3386-4845-8975-BCF8EA068A0F}"/>
+                  </a:ext>
+                </a:extLst>
+              </p:cNvPr>
+              <p:cNvSpPr/>
+              <p:nvPr/>
+            </p:nvSpPr>
+            <p:spPr>
+              <a:xfrm rot="20997034">
+                <a:off x="4160992" y="3006302"/>
+                <a:ext cx="343675" cy="207932"/>
+              </a:xfrm>
+              <a:prstGeom prst="ellipse">
+                <a:avLst/>
+              </a:prstGeom>
+              <a:solidFill>
+                <a:schemeClr val="bg1">
+                  <a:lumMod val="75000"/>
+                </a:schemeClr>
+              </a:solidFill>
+              <a:ln>
+                <a:solidFill>
+                  <a:schemeClr val="bg1">
+                    <a:lumMod val="50000"/>
+                  </a:schemeClr>
+                </a:solidFill>
+              </a:ln>
+            </p:spPr>
+            <p:style>
+              <a:lnRef idx="2">
+                <a:schemeClr val="accent1">
+                  <a:shade val="50000"/>
+                </a:schemeClr>
+              </a:lnRef>
+              <a:fillRef idx="1">
+                <a:schemeClr val="accent1"/>
+              </a:fillRef>
+              <a:effectRef idx="0">
+                <a:schemeClr val="accent1"/>
+              </a:effectRef>
+              <a:fontRef idx="minor">
+                <a:schemeClr val="lt1"/>
+              </a:fontRef>
+            </p:style>
+            <p:txBody>
+              <a:bodyPr rtlCol="0" anchor="ctr"/>
+              <a:lstStyle/>
+              <a:p>
+                <a:pPr algn="ctr"/>
+                <a:endParaRPr lang="en-US"/>
+              </a:p>
+            </p:txBody>
+          </p:sp>
+          <p:cxnSp>
+            <p:nvCxnSpPr>
+              <p:cNvPr id="40" name="Straight Connector 39">
+                <a:extLst>
+                  <a:ext uri="{FF2B5EF4-FFF2-40B4-BE49-F238E27FC236}">
+                    <a16:creationId xmlns:a16="http://schemas.microsoft.com/office/drawing/2014/main" id="{04132F47-0067-E44E-B010-6D2282F2E247}"/>
+                  </a:ext>
+                </a:extLst>
+              </p:cNvPr>
+              <p:cNvCxnSpPr>
+                <a:cxnSpLocks/>
+              </p:cNvCxnSpPr>
+              <p:nvPr/>
+            </p:nvCxnSpPr>
+            <p:spPr>
+              <a:xfrm flipH="1">
+                <a:off x="4175542" y="3109186"/>
+                <a:ext cx="41467" cy="37028"/>
+              </a:xfrm>
+              <a:prstGeom prst="line">
+                <a:avLst/>
+              </a:prstGeom>
+              <a:ln>
+                <a:solidFill>
+                  <a:schemeClr val="bg1"/>
+                </a:solidFill>
+              </a:ln>
+            </p:spPr>
+            <p:style>
+              <a:lnRef idx="1">
+                <a:schemeClr val="accent1"/>
+              </a:lnRef>
+              <a:fillRef idx="0">
+                <a:schemeClr val="accent1"/>
+              </a:fillRef>
+              <a:effectRef idx="0">
+                <a:schemeClr val="accent1"/>
+              </a:effectRef>
+              <a:fontRef idx="minor">
+                <a:schemeClr val="tx1"/>
+              </a:fontRef>
+            </p:style>
+          </p:cxnSp>
+          <p:cxnSp>
+            <p:nvCxnSpPr>
+              <p:cNvPr id="43" name="Straight Connector 42">
+                <a:extLst>
+                  <a:ext uri="{FF2B5EF4-FFF2-40B4-BE49-F238E27FC236}">
+                    <a16:creationId xmlns:a16="http://schemas.microsoft.com/office/drawing/2014/main" id="{13D448C0-129B-E248-AA7A-F160E1705FEC}"/>
+                  </a:ext>
+                </a:extLst>
+              </p:cNvPr>
+              <p:cNvCxnSpPr>
+                <a:cxnSpLocks/>
+              </p:cNvCxnSpPr>
+              <p:nvPr/>
+            </p:nvCxnSpPr>
+            <p:spPr>
+              <a:xfrm flipH="1">
+                <a:off x="4199450" y="3140696"/>
+                <a:ext cx="41467" cy="37028"/>
+              </a:xfrm>
+              <a:prstGeom prst="line">
+                <a:avLst/>
+              </a:prstGeom>
+              <a:ln>
+                <a:solidFill>
+                  <a:schemeClr val="bg1"/>
+                </a:solidFill>
+              </a:ln>
+            </p:spPr>
+            <p:style>
+              <a:lnRef idx="1">
+                <a:schemeClr val="accent1"/>
+              </a:lnRef>
+              <a:fillRef idx="0">
+                <a:schemeClr val="accent1"/>
+              </a:fillRef>
+              <a:effectRef idx="0">
+                <a:schemeClr val="accent1"/>
+              </a:effectRef>
+              <a:fontRef idx="minor">
+                <a:schemeClr val="tx1"/>
+              </a:fontRef>
+            </p:style>
+          </p:cxnSp>
+          <p:cxnSp>
+            <p:nvCxnSpPr>
+              <p:cNvPr id="48" name="Straight Connector 47">
+                <a:extLst>
+                  <a:ext uri="{FF2B5EF4-FFF2-40B4-BE49-F238E27FC236}">
+                    <a16:creationId xmlns:a16="http://schemas.microsoft.com/office/drawing/2014/main" id="{0059D9F6-FDAA-FB4E-9D50-0759BA98222B}"/>
+                  </a:ext>
+                </a:extLst>
+              </p:cNvPr>
+              <p:cNvCxnSpPr>
+                <a:cxnSpLocks/>
+              </p:cNvCxnSpPr>
+              <p:nvPr/>
+            </p:nvCxnSpPr>
+            <p:spPr>
+              <a:xfrm flipH="1">
+                <a:off x="4237936" y="3161257"/>
+                <a:ext cx="41467" cy="37028"/>
+              </a:xfrm>
+              <a:prstGeom prst="line">
+                <a:avLst/>
+              </a:prstGeom>
+              <a:ln>
+                <a:solidFill>
+                  <a:schemeClr val="bg1"/>
+                </a:solidFill>
+              </a:ln>
+            </p:spPr>
+            <p:style>
+              <a:lnRef idx="1">
+                <a:schemeClr val="accent1"/>
+              </a:lnRef>
+              <a:fillRef idx="0">
+                <a:schemeClr val="accent1"/>
+              </a:fillRef>
+              <a:effectRef idx="0">
+                <a:schemeClr val="accent1"/>
+              </a:effectRef>
+              <a:fontRef idx="minor">
+                <a:schemeClr val="tx1"/>
+              </a:fontRef>
+            </p:style>
+          </p:cxnSp>
+          <p:cxnSp>
+            <p:nvCxnSpPr>
+              <p:cNvPr id="51" name="Straight Connector 50">
+                <a:extLst>
+                  <a:ext uri="{FF2B5EF4-FFF2-40B4-BE49-F238E27FC236}">
+                    <a16:creationId xmlns:a16="http://schemas.microsoft.com/office/drawing/2014/main" id="{79605622-9A78-6B4C-94FC-0336315F3988}"/>
+                  </a:ext>
+                </a:extLst>
+              </p:cNvPr>
+              <p:cNvCxnSpPr>
+                <a:cxnSpLocks/>
+              </p:cNvCxnSpPr>
+              <p:nvPr/>
+            </p:nvCxnSpPr>
+            <p:spPr>
+              <a:xfrm flipH="1">
+                <a:off x="4290876" y="3173421"/>
+                <a:ext cx="41467" cy="37028"/>
+              </a:xfrm>
+              <a:prstGeom prst="line">
+                <a:avLst/>
+              </a:prstGeom>
+              <a:ln>
+                <a:solidFill>
+                  <a:schemeClr val="bg1"/>
+                </a:solidFill>
+              </a:ln>
+            </p:spPr>
+            <p:style>
+              <a:lnRef idx="1">
+                <a:schemeClr val="accent1"/>
+              </a:lnRef>
+              <a:fillRef idx="0">
+                <a:schemeClr val="accent1"/>
+              </a:fillRef>
+              <a:effectRef idx="0">
+                <a:schemeClr val="accent1"/>
+              </a:effectRef>
+              <a:fontRef idx="minor">
+                <a:schemeClr val="tx1"/>
+              </a:fontRef>
+            </p:style>
+          </p:cxnSp>
+          <p:sp>
+            <p:nvSpPr>
+              <p:cNvPr id="47" name="Rectangle 46">
+                <a:extLst>
+                  <a:ext uri="{FF2B5EF4-FFF2-40B4-BE49-F238E27FC236}">
+                    <a16:creationId xmlns:a16="http://schemas.microsoft.com/office/drawing/2014/main" id="{73B63520-6DBB-3F4A-A04F-989995A5459E}"/>
+                  </a:ext>
+                </a:extLst>
+              </p:cNvPr>
+              <p:cNvSpPr/>
+              <p:nvPr/>
+            </p:nvSpPr>
+            <p:spPr>
+              <a:xfrm>
+                <a:off x="4145487" y="1989055"/>
+                <a:ext cx="843856" cy="1300909"/>
+              </a:xfrm>
+              <a:prstGeom prst="rect">
+                <a:avLst/>
+              </a:prstGeom>
+              <a:noFill/>
+              <a:ln>
+                <a:solidFill>
+                  <a:schemeClr val="bg1">
+                    <a:lumMod val="85000"/>
+                  </a:schemeClr>
+                </a:solidFill>
+              </a:ln>
+            </p:spPr>
+            <p:style>
+              <a:lnRef idx="2">
+                <a:schemeClr val="accent1">
+                  <a:shade val="50000"/>
+                </a:schemeClr>
+              </a:lnRef>
+              <a:fillRef idx="1">
+                <a:schemeClr val="accent1"/>
+              </a:fillRef>
+              <a:effectRef idx="0">
+                <a:schemeClr val="accent1"/>
+              </a:effectRef>
+              <a:fontRef idx="minor">
+                <a:schemeClr val="lt1"/>
+              </a:fontRef>
+            </p:style>
+            <p:txBody>
+              <a:bodyPr rtlCol="0" anchor="ctr"/>
+              <a:lstStyle/>
+              <a:p>
+                <a:pPr algn="ctr"/>
+                <a:endParaRPr lang="en-US"/>
+              </a:p>
+            </p:txBody>
+          </p:sp>
+        </p:grpSp>
+        <p:sp>
+          <p:nvSpPr>
+            <p:cNvPr id="27" name="Rectangle 26">
+              <a:extLst>
+                <a:ext uri="{FF2B5EF4-FFF2-40B4-BE49-F238E27FC236}">
+                  <a16:creationId xmlns:a16="http://schemas.microsoft.com/office/drawing/2014/main" id="{6F150C28-A1D3-BF49-A6DC-A2507906D1B0}"/>
+                </a:ext>
+              </a:extLst>
+            </p:cNvPr>
+            <p:cNvSpPr/>
+            <p:nvPr/>
+          </p:nvSpPr>
+          <p:spPr>
+            <a:xfrm>
+              <a:off x="5003409" y="1989055"/>
+              <a:ext cx="558018" cy="1300909"/>
+            </a:xfrm>
+            <a:prstGeom prst="rect">
+              <a:avLst/>
+            </a:prstGeom>
+            <a:solidFill>
+              <a:schemeClr val="bg1"/>
+            </a:solidFill>
+            <a:ln>
+              <a:solidFill>
+                <a:schemeClr val="bg1"/>
+              </a:solidFill>
+            </a:ln>
+          </p:spPr>
+          <p:style>
+            <a:lnRef idx="2">
+              <a:schemeClr val="accent1">
+                <a:shade val="50000"/>
+              </a:schemeClr>
+            </a:lnRef>
+            <a:fillRef idx="1">
+              <a:schemeClr val="accent1"/>
+            </a:fillRef>
+            <a:effectRef idx="0">
+              <a:schemeClr val="accent1"/>
+            </a:effectRef>
+            <a:fontRef idx="minor">
+              <a:schemeClr val="lt1"/>
+            </a:fontRef>
+          </p:style>
+          <p:txBody>
+            <a:bodyPr rtlCol="0" anchor="ctr"/>
+            <a:lstStyle/>
+            <a:p>
+              <a:pPr algn="ctr"/>
+              <a:endParaRPr lang="en-US"/>
+            </a:p>
+          </p:txBody>
+        </p:sp>
+        <p:cxnSp>
+          <p:nvCxnSpPr>
+            <p:cNvPr id="29" name="Straight Connector 28">
+              <a:extLst>
+                <a:ext uri="{FF2B5EF4-FFF2-40B4-BE49-F238E27FC236}">
+                  <a16:creationId xmlns:a16="http://schemas.microsoft.com/office/drawing/2014/main" id="{F7F7F569-7214-BC4F-A46D-8DF00B93234B}"/>
+                </a:ext>
+              </a:extLst>
+            </p:cNvPr>
+            <p:cNvCxnSpPr>
+              <a:cxnSpLocks/>
+            </p:cNvCxnSpPr>
+            <p:nvPr/>
+          </p:nvCxnSpPr>
+          <p:spPr>
+            <a:xfrm flipV="1">
+              <a:off x="4330406" y="2568425"/>
+              <a:ext cx="578424" cy="553469"/>
+            </a:xfrm>
+            <a:prstGeom prst="line">
+              <a:avLst/>
+            </a:prstGeom>
+            <a:ln w="38100">
+              <a:solidFill>
+                <a:schemeClr val="accent1"/>
+              </a:solidFill>
+            </a:ln>
+          </p:spPr>
+          <p:style>
+            <a:lnRef idx="1">
+              <a:schemeClr val="accent1"/>
+            </a:lnRef>
+            <a:fillRef idx="0">
+              <a:schemeClr val="accent1"/>
+            </a:fillRef>
+            <a:effectRef idx="0">
+              <a:schemeClr val="accent1"/>
+            </a:effectRef>
+            <a:fontRef idx="minor">
+              <a:schemeClr val="tx1"/>
+            </a:fontRef>
+          </p:style>
+        </p:cxnSp>
+      </p:grpSp>
+    </p:spTree>
+    <p:extLst>
+      <p:ext uri="{BB962C8B-B14F-4D97-AF65-F5344CB8AC3E}">
+        <p14:creationId xmlns:p14="http://schemas.microsoft.com/office/powerpoint/2010/main" val="3088797898"/>
+      </p:ext>
+    </p:extLst>
+  </p:cSld>
+  <p:clrMapOvr>
+    <a:masterClrMapping/>
+  </p:clrMapOvr>
+</p:sld>
+</file>
+
+<file path=ppt/slides/slide3.xml><?xml version="1.0" encoding="utf-8"?>
+<p:sld xmlns:a="http://schemas.openxmlformats.org/drawingml/2006/main" xmlns:r="http://schemas.openxmlformats.org/officeDocument/2006/relationships" xmlns:p="http://schemas.openxmlformats.org/presentationml/2006/main">
+  <p:cSld>
+    <p:spTree>
+      <p:nvGrpSpPr>
+        <p:cNvPr id="1" name=""/>
+        <p:cNvGrpSpPr/>
+        <p:nvPr/>
+      </p:nvGrpSpPr>
+      <p:grpSpPr>
+        <a:xfrm>
+          <a:off x="0" y="0"/>
+          <a:ext cx="0" cy="0"/>
+          <a:chOff x="0" y="0"/>
+          <a:chExt cx="0" cy="0"/>
+        </a:xfrm>
+      </p:grpSpPr>
+      <p:grpSp>
+        <p:nvGrpSpPr>
+          <p:cNvPr id="26" name="Group 25">
+            <a:extLst>
+              <a:ext uri="{FF2B5EF4-FFF2-40B4-BE49-F238E27FC236}">
+                <a16:creationId xmlns:a16="http://schemas.microsoft.com/office/drawing/2014/main" id="{7E5DA20A-B142-5B42-88E6-FA5D801AA313}"/>
+              </a:ext>
+            </a:extLst>
+          </p:cNvPr>
+          <p:cNvGrpSpPr/>
+          <p:nvPr/>
+        </p:nvGrpSpPr>
+        <p:grpSpPr>
+          <a:xfrm flipH="1">
+            <a:off x="4297886" y="2143801"/>
+            <a:ext cx="1502687" cy="1300909"/>
+            <a:chOff x="4145487" y="1989055"/>
+            <a:chExt cx="1502687" cy="1300909"/>
+          </a:xfrm>
+        </p:grpSpPr>
+        <p:sp>
+          <p:nvSpPr>
+            <p:cNvPr id="5" name="Rectangle 4">
+              <a:extLst>
+                <a:ext uri="{FF2B5EF4-FFF2-40B4-BE49-F238E27FC236}">
+                  <a16:creationId xmlns:a16="http://schemas.microsoft.com/office/drawing/2014/main" id="{3F76A8F3-41A0-264E-9D30-16614BE725B1}"/>
+                </a:ext>
+              </a:extLst>
+            </p:cNvPr>
+            <p:cNvSpPr/>
+            <p:nvPr/>
+          </p:nvSpPr>
+          <p:spPr>
+            <a:xfrm>
+              <a:off x="4846623" y="2007006"/>
+              <a:ext cx="102386" cy="383943"/>
+            </a:xfrm>
+            <a:prstGeom prst="rect">
+              <a:avLst/>
+            </a:prstGeom>
+          </p:spPr>
+          <p:style>
+            <a:lnRef idx="2">
+              <a:schemeClr val="accent3">
+                <a:shade val="50000"/>
+              </a:schemeClr>
+            </a:lnRef>
+            <a:fillRef idx="1">
+              <a:schemeClr val="accent3"/>
+            </a:fillRef>
+            <a:effectRef idx="0">
+              <a:schemeClr val="accent3"/>
+            </a:effectRef>
+            <a:fontRef idx="minor">
+              <a:schemeClr val="lt1"/>
+            </a:fontRef>
+          </p:style>
+          <p:txBody>
+            <a:bodyPr rtlCol="0" anchor="ctr"/>
+            <a:lstStyle/>
+            <a:p>
+              <a:pPr algn="ctr"/>
+              <a:endParaRPr lang="en-US"/>
+            </a:p>
+          </p:txBody>
+        </p:sp>
+        <p:sp>
+          <p:nvSpPr>
+            <p:cNvPr id="2" name="Oval 1">
+              <a:extLst>
+                <a:ext uri="{FF2B5EF4-FFF2-40B4-BE49-F238E27FC236}">
+                  <a16:creationId xmlns:a16="http://schemas.microsoft.com/office/drawing/2014/main" id="{41823AD5-E3D5-6A44-BFAF-506BFE319FAC}"/>
+                </a:ext>
+              </a:extLst>
+            </p:cNvPr>
+            <p:cNvSpPr/>
+            <p:nvPr/>
+          </p:nvSpPr>
+          <p:spPr>
+            <a:xfrm>
+              <a:off x="4421894" y="2238546"/>
+              <a:ext cx="932394" cy="932394"/>
+            </a:xfrm>
+            <a:prstGeom prst="ellipse">
+              <a:avLst/>
+            </a:prstGeom>
+          </p:spPr>
+          <p:style>
+            <a:lnRef idx="2">
+              <a:schemeClr val="accent3">
+                <a:shade val="50000"/>
+              </a:schemeClr>
+            </a:lnRef>
+            <a:fillRef idx="1">
+              <a:schemeClr val="accent3"/>
+            </a:fillRef>
+            <a:effectRef idx="0">
+              <a:schemeClr val="accent3"/>
+            </a:effectRef>
+            <a:fontRef idx="minor">
+              <a:schemeClr val="lt1"/>
+            </a:fontRef>
+          </p:style>
+          <p:txBody>
+            <a:bodyPr rot="0" spcFirstLastPara="0" vertOverflow="overflow" horzOverflow="overflow" vert="horz" wrap="square" lIns="91440" tIns="45720" rIns="91440" bIns="45720" numCol="1" spcCol="0" rtlCol="0" fromWordArt="0" anchor="ctr" anchorCtr="0" forceAA="0" compatLnSpc="1">
+              <a:prstTxWarp prst="textNoShape">
+                <a:avLst/>
+              </a:prstTxWarp>
+              <a:noAutofit/>
+            </a:bodyPr>
+            <a:lstStyle/>
+            <a:p>
+              <a:pPr algn="ctr"/>
+              <a:endParaRPr lang="en-US" dirty="0"/>
+            </a:p>
+          </p:txBody>
+        </p:sp>
+        <p:sp>
+          <p:nvSpPr>
+            <p:cNvPr id="56" name="Can 55">
+              <a:extLst>
+                <a:ext uri="{FF2B5EF4-FFF2-40B4-BE49-F238E27FC236}">
+                  <a16:creationId xmlns:a16="http://schemas.microsoft.com/office/drawing/2014/main" id="{AAC1A6EF-A8F8-F44A-A4DF-6CB5A4ABD55D}"/>
+                </a:ext>
+              </a:extLst>
+            </p:cNvPr>
+            <p:cNvSpPr/>
+            <p:nvPr/>
+          </p:nvSpPr>
+          <p:spPr>
+            <a:xfrm rot="13544981">
+              <a:off x="4443044" y="2520030"/>
+              <a:ext cx="222192" cy="743133"/>
+            </a:xfrm>
+            <a:prstGeom prst="can">
+              <a:avLst/>
+            </a:prstGeom>
+            <a:solidFill>
+              <a:schemeClr val="bg1">
+                <a:lumMod val="75000"/>
+              </a:schemeClr>
+            </a:solidFill>
+            <a:ln>
+              <a:solidFill>
+                <a:schemeClr val="bg1">
+                  <a:lumMod val="50000"/>
+                </a:schemeClr>
+              </a:solidFill>
+            </a:ln>
+          </p:spPr>
+          <p:style>
+            <a:lnRef idx="2">
+              <a:schemeClr val="accent1">
+                <a:shade val="50000"/>
+              </a:schemeClr>
+            </a:lnRef>
+            <a:fillRef idx="1">
+              <a:schemeClr val="accent1"/>
+            </a:fillRef>
+            <a:effectRef idx="0">
+              <a:schemeClr val="accent1"/>
+            </a:effectRef>
+            <a:fontRef idx="minor">
+              <a:schemeClr val="lt1"/>
+            </a:fontRef>
+          </p:style>
+          <p:txBody>
+            <a:bodyPr rtlCol="0" anchor="ctr"/>
+            <a:lstStyle/>
+            <a:p>
+              <a:pPr algn="ctr"/>
+              <a:endParaRPr lang="en-US" dirty="0"/>
+            </a:p>
+          </p:txBody>
+        </p:sp>
+        <p:sp>
+          <p:nvSpPr>
+            <p:cNvPr id="4" name="Oval 3">
+              <a:extLst>
+                <a:ext uri="{FF2B5EF4-FFF2-40B4-BE49-F238E27FC236}">
+                  <a16:creationId xmlns:a16="http://schemas.microsoft.com/office/drawing/2014/main" id="{FEB4EB90-88F1-3244-A9F9-A2E192B91AAA}"/>
+                </a:ext>
+              </a:extLst>
+            </p:cNvPr>
+            <p:cNvSpPr/>
+            <p:nvPr/>
+          </p:nvSpPr>
+          <p:spPr>
+            <a:xfrm>
+              <a:off x="4846623" y="2419127"/>
+              <a:ext cx="102386" cy="277597"/>
+            </a:xfrm>
+            <a:prstGeom prst="ellipse">
+              <a:avLst/>
+            </a:prstGeom>
+            <a:solidFill>
+              <a:schemeClr val="bg1">
+                <a:lumMod val="75000"/>
+              </a:schemeClr>
+            </a:solidFill>
+            <a:ln>
+              <a:solidFill>
+                <a:schemeClr val="bg1">
+                  <a:lumMod val="50000"/>
+                </a:schemeClr>
+              </a:solidFill>
+            </a:ln>
+          </p:spPr>
+          <p:style>
+            <a:lnRef idx="2">
+              <a:schemeClr val="accent1">
+                <a:shade val="50000"/>
+              </a:schemeClr>
+            </a:lnRef>
+            <a:fillRef idx="1">
+              <a:schemeClr val="accent1"/>
+            </a:fillRef>
+            <a:effectRef idx="0">
+              <a:schemeClr val="accent1"/>
+            </a:effectRef>
+            <a:fontRef idx="minor">
+              <a:schemeClr val="lt1"/>
+            </a:fontRef>
+          </p:style>
+          <p:txBody>
+            <a:bodyPr rtlCol="0" anchor="ctr"/>
+            <a:lstStyle/>
+            <a:p>
+              <a:pPr algn="ctr"/>
+              <a:endParaRPr lang="en-US"/>
+            </a:p>
+          </p:txBody>
+        </p:sp>
+        <p:sp>
+          <p:nvSpPr>
+            <p:cNvPr id="6" name="Oval 5">
+              <a:extLst>
+                <a:ext uri="{FF2B5EF4-FFF2-40B4-BE49-F238E27FC236}">
+                  <a16:creationId xmlns:a16="http://schemas.microsoft.com/office/drawing/2014/main" id="{353558FB-3386-4845-8975-BCF8EA068A0F}"/>
+                </a:ext>
+              </a:extLst>
+            </p:cNvPr>
+            <p:cNvSpPr/>
+            <p:nvPr/>
+          </p:nvSpPr>
+          <p:spPr>
+            <a:xfrm rot="20997034">
+              <a:off x="4160992" y="3006302"/>
+              <a:ext cx="343675" cy="207932"/>
+            </a:xfrm>
+            <a:prstGeom prst="ellipse">
+              <a:avLst/>
+            </a:prstGeom>
+            <a:solidFill>
+              <a:schemeClr val="bg1">
+                <a:lumMod val="75000"/>
+              </a:schemeClr>
+            </a:solidFill>
+            <a:ln>
+              <a:solidFill>
+                <a:schemeClr val="bg1">
+                  <a:lumMod val="50000"/>
+                </a:schemeClr>
+              </a:solidFill>
+            </a:ln>
+          </p:spPr>
+          <p:style>
+            <a:lnRef idx="2">
+              <a:schemeClr val="accent1">
+                <a:shade val="50000"/>
+              </a:schemeClr>
+            </a:lnRef>
+            <a:fillRef idx="1">
+              <a:schemeClr val="accent1"/>
+            </a:fillRef>
+            <a:effectRef idx="0">
+              <a:schemeClr val="accent1"/>
+            </a:effectRef>
+            <a:fontRef idx="minor">
+              <a:schemeClr val="lt1"/>
+            </a:fontRef>
+          </p:style>
+          <p:txBody>
+            <a:bodyPr rtlCol="0" anchor="ctr"/>
+            <a:lstStyle/>
+            <a:p>
+              <a:pPr algn="ctr"/>
+              <a:endParaRPr lang="en-US"/>
+            </a:p>
+          </p:txBody>
+        </p:sp>
+        <p:cxnSp>
+          <p:nvCxnSpPr>
+            <p:cNvPr id="40" name="Straight Connector 39">
+              <a:extLst>
+                <a:ext uri="{FF2B5EF4-FFF2-40B4-BE49-F238E27FC236}">
+                  <a16:creationId xmlns:a16="http://schemas.microsoft.com/office/drawing/2014/main" id="{04132F47-0067-E44E-B010-6D2282F2E247}"/>
+                </a:ext>
+              </a:extLst>
+            </p:cNvPr>
+            <p:cNvCxnSpPr>
+              <a:cxnSpLocks/>
+            </p:cNvCxnSpPr>
+            <p:nvPr/>
+          </p:nvCxnSpPr>
+          <p:spPr>
+            <a:xfrm flipH="1">
+              <a:off x="4175542" y="3109186"/>
+              <a:ext cx="41467" cy="37028"/>
+            </a:xfrm>
+            <a:prstGeom prst="line">
+              <a:avLst/>
+            </a:prstGeom>
+            <a:ln>
+              <a:solidFill>
+                <a:schemeClr val="bg1"/>
+              </a:solidFill>
+            </a:ln>
+          </p:spPr>
+          <p:style>
+            <a:lnRef idx="1">
+              <a:schemeClr val="accent1"/>
+            </a:lnRef>
+            <a:fillRef idx="0">
+              <a:schemeClr val="accent1"/>
+            </a:fillRef>
+            <a:effectRef idx="0">
+              <a:schemeClr val="accent1"/>
+            </a:effectRef>
+            <a:fontRef idx="minor">
+              <a:schemeClr val="tx1"/>
+            </a:fontRef>
+          </p:style>
+        </p:cxnSp>
+        <p:cxnSp>
+          <p:nvCxnSpPr>
+            <p:cNvPr id="43" name="Straight Connector 42">
+              <a:extLst>
+                <a:ext uri="{FF2B5EF4-FFF2-40B4-BE49-F238E27FC236}">
+                  <a16:creationId xmlns:a16="http://schemas.microsoft.com/office/drawing/2014/main" id="{13D448C0-129B-E248-AA7A-F160E1705FEC}"/>
+                </a:ext>
+              </a:extLst>
+            </p:cNvPr>
+            <p:cNvCxnSpPr>
+              <a:cxnSpLocks/>
+            </p:cNvCxnSpPr>
+            <p:nvPr/>
+          </p:nvCxnSpPr>
+          <p:spPr>
+            <a:xfrm flipH="1">
+              <a:off x="4199450" y="3140696"/>
+              <a:ext cx="41467" cy="37028"/>
+            </a:xfrm>
+            <a:prstGeom prst="line">
+              <a:avLst/>
+            </a:prstGeom>
+            <a:ln>
+              <a:solidFill>
+                <a:schemeClr val="bg1"/>
+              </a:solidFill>
+            </a:ln>
+          </p:spPr>
+          <p:style>
+            <a:lnRef idx="1">
+              <a:schemeClr val="accent1"/>
+            </a:lnRef>
+            <a:fillRef idx="0">
+              <a:schemeClr val="accent1"/>
+            </a:fillRef>
+            <a:effectRef idx="0">
+              <a:schemeClr val="accent1"/>
+            </a:effectRef>
+            <a:fontRef idx="minor">
+              <a:schemeClr val="tx1"/>
+            </a:fontRef>
+          </p:style>
+        </p:cxnSp>
+        <p:cxnSp>
+          <p:nvCxnSpPr>
+            <p:cNvPr id="48" name="Straight Connector 47">
+              <a:extLst>
+                <a:ext uri="{FF2B5EF4-FFF2-40B4-BE49-F238E27FC236}">
+                  <a16:creationId xmlns:a16="http://schemas.microsoft.com/office/drawing/2014/main" id="{0059D9F6-FDAA-FB4E-9D50-0759BA98222B}"/>
+                </a:ext>
+              </a:extLst>
+            </p:cNvPr>
+            <p:cNvCxnSpPr>
+              <a:cxnSpLocks/>
+            </p:cNvCxnSpPr>
+            <p:nvPr/>
+          </p:nvCxnSpPr>
+          <p:spPr>
+            <a:xfrm flipH="1">
+              <a:off x="4237936" y="3161257"/>
+              <a:ext cx="41467" cy="37028"/>
+            </a:xfrm>
+            <a:prstGeom prst="line">
+              <a:avLst/>
+            </a:prstGeom>
+            <a:ln>
+              <a:solidFill>
+                <a:schemeClr val="bg1"/>
+              </a:solidFill>
+            </a:ln>
+          </p:spPr>
+          <p:style>
+            <a:lnRef idx="1">
+              <a:schemeClr val="accent1"/>
+            </a:lnRef>
+            <a:fillRef idx="0">
+              <a:schemeClr val="accent1"/>
+            </a:fillRef>
+            <a:effectRef idx="0">
+              <a:schemeClr val="accent1"/>
+            </a:effectRef>
+            <a:fontRef idx="minor">
+              <a:schemeClr val="tx1"/>
+            </a:fontRef>
+          </p:style>
+        </p:cxnSp>
+        <p:cxnSp>
+          <p:nvCxnSpPr>
+            <p:cNvPr id="51" name="Straight Connector 50">
+              <a:extLst>
+                <a:ext uri="{FF2B5EF4-FFF2-40B4-BE49-F238E27FC236}">
+                  <a16:creationId xmlns:a16="http://schemas.microsoft.com/office/drawing/2014/main" id="{79605622-9A78-6B4C-94FC-0336315F3988}"/>
+                </a:ext>
+              </a:extLst>
+            </p:cNvPr>
+            <p:cNvCxnSpPr>
+              <a:cxnSpLocks/>
+            </p:cNvCxnSpPr>
+            <p:nvPr/>
+          </p:nvCxnSpPr>
+          <p:spPr>
+            <a:xfrm flipH="1">
+              <a:off x="4290876" y="3173421"/>
+              <a:ext cx="41467" cy="37028"/>
+            </a:xfrm>
+            <a:prstGeom prst="line">
+              <a:avLst/>
+            </a:prstGeom>
+            <a:ln>
+              <a:solidFill>
+                <a:schemeClr val="bg1"/>
+              </a:solidFill>
+            </a:ln>
+          </p:spPr>
+          <p:style>
+            <a:lnRef idx="1">
+              <a:schemeClr val="accent1"/>
+            </a:lnRef>
+            <a:fillRef idx="0">
+              <a:schemeClr val="accent1"/>
+            </a:fillRef>
+            <a:effectRef idx="0">
+              <a:schemeClr val="accent1"/>
+            </a:effectRef>
+            <a:fontRef idx="minor">
+              <a:schemeClr val="tx1"/>
+            </a:fontRef>
+          </p:style>
+        </p:cxnSp>
+        <p:sp>
+          <p:nvSpPr>
+            <p:cNvPr id="47" name="Rectangle 46">
+              <a:extLst>
+                <a:ext uri="{FF2B5EF4-FFF2-40B4-BE49-F238E27FC236}">
+                  <a16:creationId xmlns:a16="http://schemas.microsoft.com/office/drawing/2014/main" id="{73B63520-6DBB-3F4A-A04F-989995A5459E}"/>
+                </a:ext>
+              </a:extLst>
+            </p:cNvPr>
+            <p:cNvSpPr/>
+            <p:nvPr/>
+          </p:nvSpPr>
+          <p:spPr>
+            <a:xfrm>
+              <a:off x="4145487" y="1989055"/>
+              <a:ext cx="1502687" cy="1300909"/>
+            </a:xfrm>
+            <a:prstGeom prst="rect">
+              <a:avLst/>
+            </a:prstGeom>
+            <a:noFill/>
+            <a:ln>
+              <a:solidFill>
+                <a:schemeClr val="bg1">
+                  <a:lumMod val="85000"/>
+                </a:schemeClr>
+              </a:solidFill>
+            </a:ln>
+          </p:spPr>
+          <p:style>
+            <a:lnRef idx="2">
+              <a:schemeClr val="accent1">
+                <a:shade val="50000"/>
+              </a:schemeClr>
+            </a:lnRef>
+            <a:fillRef idx="1">
+              <a:schemeClr val="accent1"/>
+            </a:fillRef>
+            <a:effectRef idx="0">
+              <a:schemeClr val="accent1"/>
+            </a:effectRef>
+            <a:fontRef idx="minor">
+              <a:schemeClr val="lt1"/>
+            </a:fontRef>
+          </p:style>
+          <p:txBody>
+            <a:bodyPr rtlCol="0" anchor="ctr"/>
+            <a:lstStyle/>
+            <a:p>
+              <a:pPr algn="ctr"/>
+              <a:endParaRPr lang="en-US"/>
+            </a:p>
+          </p:txBody>
+        </p:sp>
+      </p:grpSp>
+      <p:grpSp>
+        <p:nvGrpSpPr>
+          <p:cNvPr id="17" name="Group 16">
+            <a:extLst>
+              <a:ext uri="{FF2B5EF4-FFF2-40B4-BE49-F238E27FC236}">
+                <a16:creationId xmlns:a16="http://schemas.microsoft.com/office/drawing/2014/main" id="{5B127FB2-4790-A14A-ABAD-9A6FF4BEC8FA}"/>
+              </a:ext>
+            </a:extLst>
+          </p:cNvPr>
+          <p:cNvGrpSpPr/>
+          <p:nvPr/>
+        </p:nvGrpSpPr>
+        <p:grpSpPr>
           <a:xfrm>
-            <a:off x="4421894" y="2238546"/>
-            <a:ext cx="932394" cy="932394"/>
+            <a:off x="4313392" y="2571527"/>
+            <a:ext cx="788017" cy="795107"/>
+            <a:chOff x="4160992" y="2419127"/>
+            <a:chExt cx="788017" cy="795107"/>
           </a:xfrm>
-          <a:prstGeom prst="ellipse">
-            <a:avLst/>
-          </a:prstGeom>
-        </p:spPr>
-        <p:style>
-          <a:lnRef idx="2">
-            <a:schemeClr val="accent3">
-              <a:shade val="50000"/>
-            </a:schemeClr>
-          </a:lnRef>
-          <a:fillRef idx="1">
-            <a:schemeClr val="accent3"/>
-          </a:fillRef>
-          <a:effectRef idx="0">
-            <a:schemeClr val="accent3"/>
-          </a:effectRef>
-          <a:fontRef idx="minor">
-            <a:schemeClr val="lt1"/>
-          </a:fontRef>
-        </p:style>
-        <p:txBody>
-          <a:bodyPr rot="0" spcFirstLastPara="0" vertOverflow="overflow" horzOverflow="overflow" vert="horz" wrap="square" lIns="91440" tIns="45720" rIns="91440" bIns="45720" numCol="1" spcCol="0" rtlCol="0" fromWordArt="0" anchor="ctr" anchorCtr="0" forceAA="0" compatLnSpc="1">
-            <a:prstTxWarp prst="textNoShape">
+        </p:grpSpPr>
+        <p:sp>
+          <p:nvSpPr>
+            <p:cNvPr id="22" name="Can 21">
+              <a:extLst>
+                <a:ext uri="{FF2B5EF4-FFF2-40B4-BE49-F238E27FC236}">
+                  <a16:creationId xmlns:a16="http://schemas.microsoft.com/office/drawing/2014/main" id="{E8662F07-F881-F641-9A18-7460D95F5DB5}"/>
+                </a:ext>
+              </a:extLst>
+            </p:cNvPr>
+            <p:cNvSpPr/>
+            <p:nvPr/>
+          </p:nvSpPr>
+          <p:spPr>
+            <a:xfrm rot="13544981">
+              <a:off x="4443044" y="2520030"/>
+              <a:ext cx="222192" cy="743133"/>
+            </a:xfrm>
+            <a:prstGeom prst="can">
               <a:avLst/>
-            </a:prstTxWarp>
-            <a:noAutofit/>
-          </a:bodyPr>
-          <a:lstStyle/>
-          <a:p>
-            <a:pPr algn="ctr"/>
-            <a:endParaRPr lang="en-US" dirty="0"/>
-          </a:p>
-        </p:txBody>
-      </p:sp>
-      <p:sp>
-        <p:nvSpPr>
-          <p:cNvPr id="56" name="Can 55">
-            <a:extLst>
-              <a:ext uri="{FF2B5EF4-FFF2-40B4-BE49-F238E27FC236}">
-                <a16:creationId xmlns:a16="http://schemas.microsoft.com/office/drawing/2014/main" id="{AAC1A6EF-A8F8-F44A-A4DF-6CB5A4ABD55D}"/>
-              </a:ext>
-            </a:extLst>
-          </p:cNvPr>
-          <p:cNvSpPr/>
-          <p:nvPr/>
-        </p:nvSpPr>
-        <p:spPr>
-          <a:xfrm rot="13544981">
-            <a:off x="4371453" y="2531217"/>
-            <a:ext cx="357122" cy="743133"/>
-          </a:xfrm>
-          <a:prstGeom prst="can">
-            <a:avLst/>
-          </a:prstGeom>
-        </p:spPr>
-        <p:style>
-          <a:lnRef idx="2">
-            <a:schemeClr val="accent1">
-              <a:shade val="50000"/>
-            </a:schemeClr>
-          </a:lnRef>
-          <a:fillRef idx="1">
-            <a:schemeClr val="accent1"/>
-          </a:fillRef>
-          <a:effectRef idx="0">
-            <a:schemeClr val="accent1"/>
-          </a:effectRef>
-          <a:fontRef idx="minor">
-            <a:schemeClr val="lt1"/>
-          </a:fontRef>
-        </p:style>
-        <p:txBody>
-          <a:bodyPr rtlCol="0" anchor="ctr"/>
-          <a:lstStyle/>
-          <a:p>
-            <a:pPr algn="ctr"/>
-            <a:endParaRPr lang="en-US" dirty="0"/>
-          </a:p>
-        </p:txBody>
-      </p:sp>
-      <p:sp>
-        <p:nvSpPr>
-          <p:cNvPr id="4" name="Oval 3">
-            <a:extLst>
-              <a:ext uri="{FF2B5EF4-FFF2-40B4-BE49-F238E27FC236}">
-                <a16:creationId xmlns:a16="http://schemas.microsoft.com/office/drawing/2014/main" id="{FEB4EB90-88F1-3244-A9F9-A2E192B91AAA}"/>
-              </a:ext>
-            </a:extLst>
-          </p:cNvPr>
-          <p:cNvSpPr/>
-          <p:nvPr/>
-        </p:nvSpPr>
-        <p:spPr>
-          <a:xfrm>
-            <a:off x="4846623" y="2419127"/>
-            <a:ext cx="102386" cy="277597"/>
-          </a:xfrm>
-          <a:prstGeom prst="ellipse">
-            <a:avLst/>
-          </a:prstGeom>
-          <a:solidFill>
-            <a:schemeClr val="bg1">
-              <a:lumMod val="75000"/>
-            </a:schemeClr>
-          </a:solidFill>
-        </p:spPr>
-        <p:style>
-          <a:lnRef idx="2">
-            <a:schemeClr val="accent1">
-              <a:shade val="50000"/>
-            </a:schemeClr>
-          </a:lnRef>
-          <a:fillRef idx="1">
-            <a:schemeClr val="accent1"/>
-          </a:fillRef>
-          <a:effectRef idx="0">
-            <a:schemeClr val="accent1"/>
-          </a:effectRef>
-          <a:fontRef idx="minor">
-            <a:schemeClr val="lt1"/>
-          </a:fontRef>
-        </p:style>
-        <p:txBody>
-          <a:bodyPr rtlCol="0" anchor="ctr"/>
-          <a:lstStyle/>
-          <a:p>
-            <a:pPr algn="ctr"/>
-            <a:endParaRPr lang="en-US"/>
-          </a:p>
-        </p:txBody>
-      </p:sp>
+            </a:prstGeom>
+            <a:solidFill>
+              <a:schemeClr val="bg1">
+                <a:lumMod val="75000"/>
+              </a:schemeClr>
+            </a:solidFill>
+            <a:ln>
+              <a:solidFill>
+                <a:schemeClr val="bg1">
+                  <a:lumMod val="50000"/>
+                </a:schemeClr>
+              </a:solidFill>
+            </a:ln>
+          </p:spPr>
+          <p:style>
+            <a:lnRef idx="2">
+              <a:schemeClr val="accent1">
+                <a:shade val="50000"/>
+              </a:schemeClr>
+            </a:lnRef>
+            <a:fillRef idx="1">
+              <a:schemeClr val="accent1"/>
+            </a:fillRef>
+            <a:effectRef idx="0">
+              <a:schemeClr val="accent1"/>
+            </a:effectRef>
+            <a:fontRef idx="minor">
+              <a:schemeClr val="lt1"/>
+            </a:fontRef>
+          </p:style>
+          <p:txBody>
+            <a:bodyPr rtlCol="0" anchor="ctr"/>
+            <a:lstStyle/>
+            <a:p>
+              <a:pPr algn="ctr"/>
+              <a:endParaRPr lang="en-US" dirty="0"/>
+            </a:p>
+          </p:txBody>
+        </p:sp>
+        <p:sp>
+          <p:nvSpPr>
+            <p:cNvPr id="23" name="Oval 22">
+              <a:extLst>
+                <a:ext uri="{FF2B5EF4-FFF2-40B4-BE49-F238E27FC236}">
+                  <a16:creationId xmlns:a16="http://schemas.microsoft.com/office/drawing/2014/main" id="{31F5F955-F975-2B40-AA13-C4FA1FB2AF7C}"/>
+                </a:ext>
+              </a:extLst>
+            </p:cNvPr>
+            <p:cNvSpPr/>
+            <p:nvPr/>
+          </p:nvSpPr>
+          <p:spPr>
+            <a:xfrm>
+              <a:off x="4846623" y="2419127"/>
+              <a:ext cx="102386" cy="277597"/>
+            </a:xfrm>
+            <a:prstGeom prst="ellipse">
+              <a:avLst/>
+            </a:prstGeom>
+            <a:solidFill>
+              <a:schemeClr val="bg1">
+                <a:lumMod val="75000"/>
+              </a:schemeClr>
+            </a:solidFill>
+            <a:ln>
+              <a:solidFill>
+                <a:schemeClr val="bg1">
+                  <a:lumMod val="50000"/>
+                </a:schemeClr>
+              </a:solidFill>
+            </a:ln>
+          </p:spPr>
+          <p:style>
+            <a:lnRef idx="2">
+              <a:schemeClr val="accent1">
+                <a:shade val="50000"/>
+              </a:schemeClr>
+            </a:lnRef>
+            <a:fillRef idx="1">
+              <a:schemeClr val="accent1"/>
+            </a:fillRef>
+            <a:effectRef idx="0">
+              <a:schemeClr val="accent1"/>
+            </a:effectRef>
+            <a:fontRef idx="minor">
+              <a:schemeClr val="lt1"/>
+            </a:fontRef>
+          </p:style>
+          <p:txBody>
+            <a:bodyPr rtlCol="0" anchor="ctr"/>
+            <a:lstStyle/>
+            <a:p>
+              <a:pPr algn="ctr"/>
+              <a:endParaRPr lang="en-US"/>
+            </a:p>
+          </p:txBody>
+        </p:sp>
+        <p:sp>
+          <p:nvSpPr>
+            <p:cNvPr id="24" name="Oval 23">
+              <a:extLst>
+                <a:ext uri="{FF2B5EF4-FFF2-40B4-BE49-F238E27FC236}">
+                  <a16:creationId xmlns:a16="http://schemas.microsoft.com/office/drawing/2014/main" id="{71F8616C-93E5-7F47-94E7-D8A90A65E1AA}"/>
+                </a:ext>
+              </a:extLst>
+            </p:cNvPr>
+            <p:cNvSpPr/>
+            <p:nvPr/>
+          </p:nvSpPr>
+          <p:spPr>
+            <a:xfrm rot="20997034">
+              <a:off x="4160992" y="3006302"/>
+              <a:ext cx="343675" cy="207932"/>
+            </a:xfrm>
+            <a:prstGeom prst="ellipse">
+              <a:avLst/>
+            </a:prstGeom>
+            <a:solidFill>
+              <a:schemeClr val="bg1">
+                <a:lumMod val="75000"/>
+              </a:schemeClr>
+            </a:solidFill>
+            <a:ln>
+              <a:solidFill>
+                <a:schemeClr val="bg1">
+                  <a:lumMod val="50000"/>
+                </a:schemeClr>
+              </a:solidFill>
+            </a:ln>
+          </p:spPr>
+          <p:style>
+            <a:lnRef idx="2">
+              <a:schemeClr val="accent1">
+                <a:shade val="50000"/>
+              </a:schemeClr>
+            </a:lnRef>
+            <a:fillRef idx="1">
+              <a:schemeClr val="accent1"/>
+            </a:fillRef>
+            <a:effectRef idx="0">
+              <a:schemeClr val="accent1"/>
+            </a:effectRef>
+            <a:fontRef idx="minor">
+              <a:schemeClr val="lt1"/>
+            </a:fontRef>
+          </p:style>
+          <p:txBody>
+            <a:bodyPr rtlCol="0" anchor="ctr"/>
+            <a:lstStyle/>
+            <a:p>
+              <a:pPr algn="ctr"/>
+              <a:endParaRPr lang="en-US"/>
+            </a:p>
+          </p:txBody>
+        </p:sp>
+        <p:cxnSp>
+          <p:nvCxnSpPr>
+            <p:cNvPr id="25" name="Straight Connector 24">
+              <a:extLst>
+                <a:ext uri="{FF2B5EF4-FFF2-40B4-BE49-F238E27FC236}">
+                  <a16:creationId xmlns:a16="http://schemas.microsoft.com/office/drawing/2014/main" id="{C9883EBD-AE9B-B84D-AE0B-CAB84767BFDE}"/>
+                </a:ext>
+              </a:extLst>
+            </p:cNvPr>
+            <p:cNvCxnSpPr>
+              <a:cxnSpLocks/>
+            </p:cNvCxnSpPr>
+            <p:nvPr/>
+          </p:nvCxnSpPr>
+          <p:spPr>
+            <a:xfrm flipH="1">
+              <a:off x="4175542" y="3109186"/>
+              <a:ext cx="41467" cy="37028"/>
+            </a:xfrm>
+            <a:prstGeom prst="line">
+              <a:avLst/>
+            </a:prstGeom>
+            <a:ln>
+              <a:solidFill>
+                <a:schemeClr val="bg1"/>
+              </a:solidFill>
+            </a:ln>
+          </p:spPr>
+          <p:style>
+            <a:lnRef idx="1">
+              <a:schemeClr val="accent1"/>
+            </a:lnRef>
+            <a:fillRef idx="0">
+              <a:schemeClr val="accent1"/>
+            </a:fillRef>
+            <a:effectRef idx="0">
+              <a:schemeClr val="accent1"/>
+            </a:effectRef>
+            <a:fontRef idx="minor">
+              <a:schemeClr val="tx1"/>
+            </a:fontRef>
+          </p:style>
+        </p:cxnSp>
+        <p:cxnSp>
+          <p:nvCxnSpPr>
+            <p:cNvPr id="28" name="Straight Connector 27">
+              <a:extLst>
+                <a:ext uri="{FF2B5EF4-FFF2-40B4-BE49-F238E27FC236}">
+                  <a16:creationId xmlns:a16="http://schemas.microsoft.com/office/drawing/2014/main" id="{F535C826-F972-8C4A-BA16-7A0D5397F772}"/>
+                </a:ext>
+              </a:extLst>
+            </p:cNvPr>
+            <p:cNvCxnSpPr>
+              <a:cxnSpLocks/>
+            </p:cNvCxnSpPr>
+            <p:nvPr/>
+          </p:nvCxnSpPr>
+          <p:spPr>
+            <a:xfrm flipH="1">
+              <a:off x="4199450" y="3140696"/>
+              <a:ext cx="41467" cy="37028"/>
+            </a:xfrm>
+            <a:prstGeom prst="line">
+              <a:avLst/>
+            </a:prstGeom>
+            <a:ln>
+              <a:solidFill>
+                <a:schemeClr val="bg1"/>
+              </a:solidFill>
+            </a:ln>
+          </p:spPr>
+          <p:style>
+            <a:lnRef idx="1">
+              <a:schemeClr val="accent1"/>
+            </a:lnRef>
+            <a:fillRef idx="0">
+              <a:schemeClr val="accent1"/>
+            </a:fillRef>
+            <a:effectRef idx="0">
+              <a:schemeClr val="accent1"/>
+            </a:effectRef>
+            <a:fontRef idx="minor">
+              <a:schemeClr val="tx1"/>
+            </a:fontRef>
+          </p:style>
+        </p:cxnSp>
+        <p:cxnSp>
+          <p:nvCxnSpPr>
+            <p:cNvPr id="30" name="Straight Connector 29">
+              <a:extLst>
+                <a:ext uri="{FF2B5EF4-FFF2-40B4-BE49-F238E27FC236}">
+                  <a16:creationId xmlns:a16="http://schemas.microsoft.com/office/drawing/2014/main" id="{237B897D-2DB1-704D-9181-A344517DB101}"/>
+                </a:ext>
+              </a:extLst>
+            </p:cNvPr>
+            <p:cNvCxnSpPr>
+              <a:cxnSpLocks/>
+            </p:cNvCxnSpPr>
+            <p:nvPr/>
+          </p:nvCxnSpPr>
+          <p:spPr>
+            <a:xfrm flipH="1">
+              <a:off x="4237936" y="3161257"/>
+              <a:ext cx="41467" cy="37028"/>
+            </a:xfrm>
+            <a:prstGeom prst="line">
+              <a:avLst/>
+            </a:prstGeom>
+            <a:ln>
+              <a:solidFill>
+                <a:schemeClr val="bg1"/>
+              </a:solidFill>
+            </a:ln>
+          </p:spPr>
+          <p:style>
+            <a:lnRef idx="1">
+              <a:schemeClr val="accent1"/>
+            </a:lnRef>
+            <a:fillRef idx="0">
+              <a:schemeClr val="accent1"/>
+            </a:fillRef>
+            <a:effectRef idx="0">
+              <a:schemeClr val="accent1"/>
+            </a:effectRef>
+            <a:fontRef idx="minor">
+              <a:schemeClr val="tx1"/>
+            </a:fontRef>
+          </p:style>
+        </p:cxnSp>
+        <p:cxnSp>
+          <p:nvCxnSpPr>
+            <p:cNvPr id="31" name="Straight Connector 30">
+              <a:extLst>
+                <a:ext uri="{FF2B5EF4-FFF2-40B4-BE49-F238E27FC236}">
+                  <a16:creationId xmlns:a16="http://schemas.microsoft.com/office/drawing/2014/main" id="{2FAEBA90-2091-7D4D-AF30-BA70E00F20AF}"/>
+                </a:ext>
+              </a:extLst>
+            </p:cNvPr>
+            <p:cNvCxnSpPr>
+              <a:cxnSpLocks/>
+            </p:cNvCxnSpPr>
+            <p:nvPr/>
+          </p:nvCxnSpPr>
+          <p:spPr>
+            <a:xfrm flipH="1">
+              <a:off x="4290876" y="3173421"/>
+              <a:ext cx="41467" cy="37028"/>
+            </a:xfrm>
+            <a:prstGeom prst="line">
+              <a:avLst/>
+            </a:prstGeom>
+            <a:ln>
+              <a:solidFill>
+                <a:schemeClr val="bg1"/>
+              </a:solidFill>
+            </a:ln>
+          </p:spPr>
+          <p:style>
+            <a:lnRef idx="1">
+              <a:schemeClr val="accent1"/>
+            </a:lnRef>
+            <a:fillRef idx="0">
+              <a:schemeClr val="accent1"/>
+            </a:fillRef>
+            <a:effectRef idx="0">
+              <a:schemeClr val="accent1"/>
+            </a:effectRef>
+            <a:fontRef idx="minor">
+              <a:schemeClr val="tx1"/>
+            </a:fontRef>
+          </p:style>
+        </p:cxnSp>
+      </p:grpSp>
       <p:cxnSp>
         <p:nvCxnSpPr>
-          <p:cNvPr id="16" name="Straight Connector 15">
-            <a:extLst>
-              <a:ext uri="{FF2B5EF4-FFF2-40B4-BE49-F238E27FC236}">
-                <a16:creationId xmlns:a16="http://schemas.microsoft.com/office/drawing/2014/main" id="{ECA0BEE5-6C32-F241-9143-3094959EC649}"/>
+          <p:cNvPr id="33" name="Straight Connector 32">
+            <a:extLst>
+              <a:ext uri="{FF2B5EF4-FFF2-40B4-BE49-F238E27FC236}">
+                <a16:creationId xmlns:a16="http://schemas.microsoft.com/office/drawing/2014/main" id="{8EA859CC-56FC-BD4C-BD12-37BB6CB6C1EB}"/>
               </a:ext>
             </a:extLst>
           </p:cNvPr>
@@ -3535,18 +5561,17 @@
           <p:nvPr/>
         </p:nvCxnSpPr>
         <p:spPr>
-          <a:xfrm rot="2700000">
-            <a:off x="4616785" y="2455077"/>
-            <a:ext cx="0" cy="794875"/>
+          <a:xfrm>
+            <a:off x="4474097" y="3267773"/>
+            <a:ext cx="1148294" cy="11137"/>
           </a:xfrm>
           <a:prstGeom prst="line">
             <a:avLst/>
           </a:prstGeom>
-          <a:ln w="28575">
+          <a:ln w="38100">
             <a:solidFill>
-              <a:schemeClr val="tx1"/>
+              <a:srgbClr val="FF0000"/>
             </a:solidFill>
-            <a:prstDash val="dash"/>
           </a:ln>
         </p:spPr>
         <p:style>
@@ -3564,12 +5589,42 @@
           </a:fontRef>
         </p:style>
       </p:cxnSp>
+    </p:spTree>
+    <p:extLst>
+      <p:ext uri="{BB962C8B-B14F-4D97-AF65-F5344CB8AC3E}">
+        <p14:creationId xmlns:p14="http://schemas.microsoft.com/office/powerpoint/2010/main" val="2858319899"/>
+      </p:ext>
+    </p:extLst>
+  </p:cSld>
+  <p:clrMapOvr>
+    <a:masterClrMapping/>
+  </p:clrMapOvr>
+</p:sld>
+</file>
+
+<file path=ppt/slides/slide4.xml><?xml version="1.0" encoding="utf-8"?>
+<p:sld xmlns:a="http://schemas.openxmlformats.org/drawingml/2006/main" xmlns:r="http://schemas.openxmlformats.org/officeDocument/2006/relationships" xmlns:p="http://schemas.openxmlformats.org/presentationml/2006/main">
+  <p:cSld>
+    <p:spTree>
+      <p:nvGrpSpPr>
+        <p:cNvPr id="1" name=""/>
+        <p:cNvGrpSpPr/>
+        <p:nvPr/>
+      </p:nvGrpSpPr>
+      <p:grpSpPr>
+        <a:xfrm>
+          <a:off x="0" y="0"/>
+          <a:ext cx="0" cy="0"/>
+          <a:chOff x="0" y="0"/>
+          <a:chExt cx="0" cy="0"/>
+        </a:xfrm>
+      </p:grpSpPr>
       <p:sp>
         <p:nvSpPr>
-          <p:cNvPr id="47" name="Rectangle 46">
-            <a:extLst>
-              <a:ext uri="{FF2B5EF4-FFF2-40B4-BE49-F238E27FC236}">
-                <a16:creationId xmlns:a16="http://schemas.microsoft.com/office/drawing/2014/main" id="{73B63520-6DBB-3F4A-A04F-989995A5459E}"/>
+          <p:cNvPr id="35" name="Rectangle 34">
+            <a:extLst>
+              <a:ext uri="{FF2B5EF4-FFF2-40B4-BE49-F238E27FC236}">
+                <a16:creationId xmlns:a16="http://schemas.microsoft.com/office/drawing/2014/main" id="{F7EAC529-7D02-8441-8F8D-940D54FFBF72}"/>
               </a:ext>
             </a:extLst>
           </p:cNvPr>
@@ -3577,9 +5632,9 @@
           <p:nvPr/>
         </p:nvSpPr>
         <p:spPr>
-          <a:xfrm>
-            <a:off x="4157115" y="1989055"/>
-            <a:ext cx="1482748" cy="1300909"/>
+          <a:xfrm flipH="1">
+            <a:off x="4421619" y="2598529"/>
+            <a:ext cx="945788" cy="1300909"/>
           </a:xfrm>
           <a:prstGeom prst="rect">
             <a:avLst/>
@@ -3620,10 +5675,10 @@
       </p:sp>
       <p:grpSp>
         <p:nvGrpSpPr>
-          <p:cNvPr id="3" name="Group 2">
-            <a:extLst>
-              <a:ext uri="{FF2B5EF4-FFF2-40B4-BE49-F238E27FC236}">
-                <a16:creationId xmlns:a16="http://schemas.microsoft.com/office/drawing/2014/main" id="{93428608-1AF8-D54E-ADED-F68681C8F411}"/>
+          <p:cNvPr id="20" name="Group 19">
+            <a:extLst>
+              <a:ext uri="{FF2B5EF4-FFF2-40B4-BE49-F238E27FC236}">
+                <a16:creationId xmlns:a16="http://schemas.microsoft.com/office/drawing/2014/main" id="{C45A602E-48E9-074C-A529-C6FFCE513BB5}"/>
               </a:ext>
             </a:extLst>
           </p:cNvPr>
@@ -3632,18 +5687,18 @@
         </p:nvGrpSpPr>
         <p:grpSpPr>
           <a:xfrm>
-            <a:off x="4871448" y="2455077"/>
-            <a:ext cx="743133" cy="794875"/>
-            <a:chOff x="7009524" y="2455077"/>
-            <a:chExt cx="743133" cy="794875"/>
+            <a:off x="4442586" y="2607864"/>
+            <a:ext cx="903855" cy="1261495"/>
+            <a:chOff x="4442586" y="2243822"/>
+            <a:chExt cx="1171575" cy="1625533"/>
           </a:xfrm>
         </p:grpSpPr>
         <p:sp>
           <p:nvSpPr>
-            <p:cNvPr id="61" name="Can 60">
+            <p:cNvPr id="36" name="Oval 35">
               <a:extLst>
                 <a:ext uri="{FF2B5EF4-FFF2-40B4-BE49-F238E27FC236}">
-                  <a16:creationId xmlns:a16="http://schemas.microsoft.com/office/drawing/2014/main" id="{4BEC0779-5EE5-8D4C-AB52-AFDC72A1D091}"/>
+                  <a16:creationId xmlns:a16="http://schemas.microsoft.com/office/drawing/2014/main" id="{9B665120-5C66-6F45-8AB2-213725D77659}"/>
                 </a:ext>
               </a:extLst>
             </p:cNvPr>
@@ -3651,13 +5706,360 @@
             <p:nvPr/>
           </p:nvSpPr>
           <p:spPr>
-            <a:xfrm rot="8055019" flipH="1">
-              <a:off x="7202530" y="2531217"/>
-              <a:ext cx="357122" cy="743133"/>
+            <a:xfrm rot="14260250">
+              <a:off x="5016085" y="3163737"/>
+              <a:ext cx="510962" cy="549916"/>
             </a:xfrm>
-            <a:prstGeom prst="can">
+            <a:prstGeom prst="ellipse">
               <a:avLst/>
             </a:prstGeom>
+          </p:spPr>
+          <p:style>
+            <a:lnRef idx="1">
+              <a:schemeClr val="dk1"/>
+            </a:lnRef>
+            <a:fillRef idx="2">
+              <a:schemeClr val="dk1"/>
+            </a:fillRef>
+            <a:effectRef idx="1">
+              <a:schemeClr val="dk1"/>
+            </a:effectRef>
+            <a:fontRef idx="minor">
+              <a:schemeClr val="dk1"/>
+            </a:fontRef>
+          </p:style>
+          <p:txBody>
+            <a:bodyPr rot="0" spcFirstLastPara="0" vertOverflow="overflow" horzOverflow="overflow" vert="horz" wrap="square" lIns="91440" tIns="45720" rIns="91440" bIns="45720" numCol="1" spcCol="0" rtlCol="0" fromWordArt="0" anchor="ctr" anchorCtr="0" forceAA="0" compatLnSpc="1">
+              <a:prstTxWarp prst="textNoShape">
+                <a:avLst/>
+              </a:prstTxWarp>
+              <a:noAutofit/>
+            </a:bodyPr>
+            <a:lstStyle/>
+            <a:p>
+              <a:pPr algn="ctr"/>
+              <a:endParaRPr lang="en-US"/>
+            </a:p>
+          </p:txBody>
+        </p:sp>
+        <p:grpSp>
+          <p:nvGrpSpPr>
+            <p:cNvPr id="99" name="Group 98">
+              <a:extLst>
+                <a:ext uri="{FF2B5EF4-FFF2-40B4-BE49-F238E27FC236}">
+                  <a16:creationId xmlns:a16="http://schemas.microsoft.com/office/drawing/2014/main" id="{1CD66E8B-4FFF-2E41-A755-7EEBDF68C968}"/>
+                </a:ext>
+              </a:extLst>
+            </p:cNvPr>
+            <p:cNvGrpSpPr/>
+            <p:nvPr/>
+          </p:nvGrpSpPr>
+          <p:grpSpPr>
+            <a:xfrm>
+              <a:off x="4442586" y="2243822"/>
+              <a:ext cx="1171575" cy="1625533"/>
+              <a:chOff x="4442586" y="2243822"/>
+              <a:chExt cx="1171575" cy="1625533"/>
+            </a:xfrm>
+          </p:grpSpPr>
+          <p:sp>
+            <p:nvSpPr>
+              <p:cNvPr id="67" name="Oval 66">
+                <a:extLst>
+                  <a:ext uri="{FF2B5EF4-FFF2-40B4-BE49-F238E27FC236}">
+                    <a16:creationId xmlns:a16="http://schemas.microsoft.com/office/drawing/2014/main" id="{F50C8471-61EC-BE4C-9F35-C7A559211D01}"/>
+                  </a:ext>
+                </a:extLst>
+              </p:cNvPr>
+              <p:cNvSpPr/>
+              <p:nvPr/>
+            </p:nvSpPr>
+            <p:spPr>
+              <a:xfrm rot="7339750" flipH="1">
+                <a:off x="4529700" y="3154597"/>
+                <a:ext cx="510962" cy="549916"/>
+              </a:xfrm>
+              <a:prstGeom prst="ellipse">
+                <a:avLst/>
+              </a:prstGeom>
+            </p:spPr>
+            <p:style>
+              <a:lnRef idx="1">
+                <a:schemeClr val="dk1"/>
+              </a:lnRef>
+              <a:fillRef idx="2">
+                <a:schemeClr val="dk1"/>
+              </a:fillRef>
+              <a:effectRef idx="1">
+                <a:schemeClr val="dk1"/>
+              </a:effectRef>
+              <a:fontRef idx="minor">
+                <a:schemeClr val="dk1"/>
+              </a:fontRef>
+            </p:style>
+            <p:txBody>
+              <a:bodyPr rot="0" spcFirstLastPara="0" vertOverflow="overflow" horzOverflow="overflow" vert="horz" wrap="square" lIns="91440" tIns="45720" rIns="91440" bIns="45720" numCol="1" spcCol="0" rtlCol="0" fromWordArt="0" anchor="ctr" anchorCtr="0" forceAA="0" compatLnSpc="1">
+                <a:prstTxWarp prst="textNoShape">
+                  <a:avLst/>
+                </a:prstTxWarp>
+                <a:noAutofit/>
+              </a:bodyPr>
+              <a:lstStyle/>
+              <a:p>
+                <a:pPr algn="ctr"/>
+                <a:endParaRPr lang="en-US"/>
+              </a:p>
+            </p:txBody>
+          </p:sp>
+          <p:sp>
+            <p:nvSpPr>
+              <p:cNvPr id="55" name="Triangle 54">
+                <a:extLst>
+                  <a:ext uri="{FF2B5EF4-FFF2-40B4-BE49-F238E27FC236}">
+                    <a16:creationId xmlns:a16="http://schemas.microsoft.com/office/drawing/2014/main" id="{F1AA8FBF-5A5E-4947-9BF4-87EAFBF92066}"/>
+                  </a:ext>
+                </a:extLst>
+              </p:cNvPr>
+              <p:cNvSpPr/>
+              <p:nvPr/>
+            </p:nvSpPr>
+            <p:spPr>
+              <a:xfrm rot="10800000" flipH="1">
+                <a:off x="4442586" y="2384981"/>
+                <a:ext cx="1171575" cy="1484374"/>
+              </a:xfrm>
+              <a:prstGeom prst="triangle">
+                <a:avLst/>
+              </a:prstGeom>
+            </p:spPr>
+            <p:style>
+              <a:lnRef idx="1">
+                <a:schemeClr val="dk1"/>
+              </a:lnRef>
+              <a:fillRef idx="2">
+                <a:schemeClr val="dk1"/>
+              </a:fillRef>
+              <a:effectRef idx="1">
+                <a:schemeClr val="dk1"/>
+              </a:effectRef>
+              <a:fontRef idx="minor">
+                <a:schemeClr val="dk1"/>
+              </a:fontRef>
+            </p:style>
+            <p:txBody>
+              <a:bodyPr rtlCol="0" anchor="ctr"/>
+              <a:lstStyle/>
+              <a:p>
+                <a:pPr algn="ctr"/>
+                <a:endParaRPr lang="en-US" dirty="0"/>
+              </a:p>
+            </p:txBody>
+          </p:sp>
+          <p:cxnSp>
+            <p:nvCxnSpPr>
+              <p:cNvPr id="71" name="Straight Connector 70">
+                <a:extLst>
+                  <a:ext uri="{FF2B5EF4-FFF2-40B4-BE49-F238E27FC236}">
+                    <a16:creationId xmlns:a16="http://schemas.microsoft.com/office/drawing/2014/main" id="{0A219D18-D9D9-E343-8FC4-989F88AA51F0}"/>
+                  </a:ext>
+                </a:extLst>
+              </p:cNvPr>
+              <p:cNvCxnSpPr/>
+              <p:nvPr/>
+            </p:nvCxnSpPr>
+            <p:spPr>
+              <a:xfrm>
+                <a:off x="5034642" y="3530586"/>
+                <a:ext cx="0" cy="108160"/>
+              </a:xfrm>
+              <a:prstGeom prst="line">
+                <a:avLst/>
+              </a:prstGeom>
+              <a:ln w="38100">
+                <a:solidFill>
+                  <a:schemeClr val="bg1"/>
+                </a:solidFill>
+              </a:ln>
+            </p:spPr>
+            <p:style>
+              <a:lnRef idx="1">
+                <a:schemeClr val="accent1"/>
+              </a:lnRef>
+              <a:fillRef idx="0">
+                <a:schemeClr val="accent1"/>
+              </a:fillRef>
+              <a:effectRef idx="0">
+                <a:schemeClr val="accent1"/>
+              </a:effectRef>
+              <a:fontRef idx="minor">
+                <a:schemeClr val="tx1"/>
+              </a:fontRef>
+            </p:style>
+          </p:cxnSp>
+          <p:cxnSp>
+            <p:nvCxnSpPr>
+              <p:cNvPr id="72" name="Straight Connector 71">
+                <a:extLst>
+                  <a:ext uri="{FF2B5EF4-FFF2-40B4-BE49-F238E27FC236}">
+                    <a16:creationId xmlns:a16="http://schemas.microsoft.com/office/drawing/2014/main" id="{FC1B5090-4092-4145-BF1A-DED9FEF6618F}"/>
+                  </a:ext>
+                </a:extLst>
+              </p:cNvPr>
+              <p:cNvCxnSpPr>
+                <a:cxnSpLocks/>
+              </p:cNvCxnSpPr>
+              <p:nvPr/>
+            </p:nvCxnSpPr>
+            <p:spPr>
+              <a:xfrm>
+                <a:off x="4933488" y="3469736"/>
+                <a:ext cx="101154" cy="65947"/>
+              </a:xfrm>
+              <a:prstGeom prst="line">
+                <a:avLst/>
+              </a:prstGeom>
+              <a:ln w="38100">
+                <a:solidFill>
+                  <a:schemeClr val="bg1"/>
+                </a:solidFill>
+              </a:ln>
+            </p:spPr>
+            <p:style>
+              <a:lnRef idx="1">
+                <a:schemeClr val="accent1"/>
+              </a:lnRef>
+              <a:fillRef idx="0">
+                <a:schemeClr val="accent1"/>
+              </a:fillRef>
+              <a:effectRef idx="0">
+                <a:schemeClr val="accent1"/>
+              </a:effectRef>
+              <a:fontRef idx="minor">
+                <a:schemeClr val="tx1"/>
+              </a:fontRef>
+            </p:style>
+          </p:cxnSp>
+          <p:cxnSp>
+            <p:nvCxnSpPr>
+              <p:cNvPr id="75" name="Straight Connector 74">
+                <a:extLst>
+                  <a:ext uri="{FF2B5EF4-FFF2-40B4-BE49-F238E27FC236}">
+                    <a16:creationId xmlns:a16="http://schemas.microsoft.com/office/drawing/2014/main" id="{25B56C43-9DDC-2E43-8BED-179D4E652E41}"/>
+                  </a:ext>
+                </a:extLst>
+              </p:cNvPr>
+              <p:cNvCxnSpPr>
+                <a:cxnSpLocks/>
+              </p:cNvCxnSpPr>
+              <p:nvPr/>
+            </p:nvCxnSpPr>
+            <p:spPr>
+              <a:xfrm flipH="1">
+                <a:off x="5034642" y="3469735"/>
+                <a:ext cx="101154" cy="65947"/>
+              </a:xfrm>
+              <a:prstGeom prst="line">
+                <a:avLst/>
+              </a:prstGeom>
+              <a:ln w="38100">
+                <a:solidFill>
+                  <a:schemeClr val="bg1"/>
+                </a:solidFill>
+              </a:ln>
+            </p:spPr>
+            <p:style>
+              <a:lnRef idx="1">
+                <a:schemeClr val="accent1"/>
+              </a:lnRef>
+              <a:fillRef idx="0">
+                <a:schemeClr val="accent1"/>
+              </a:fillRef>
+              <a:effectRef idx="0">
+                <a:schemeClr val="accent1"/>
+              </a:effectRef>
+              <a:fontRef idx="minor">
+                <a:schemeClr val="tx1"/>
+              </a:fontRef>
+            </p:style>
+          </p:cxnSp>
+          <p:cxnSp>
+            <p:nvCxnSpPr>
+              <p:cNvPr id="91" name="Straight Connector 90">
+                <a:extLst>
+                  <a:ext uri="{FF2B5EF4-FFF2-40B4-BE49-F238E27FC236}">
+                    <a16:creationId xmlns:a16="http://schemas.microsoft.com/office/drawing/2014/main" id="{609D9B8B-55A7-0445-BFC5-420BCDEB5FAC}"/>
+                  </a:ext>
+                </a:extLst>
+              </p:cNvPr>
+              <p:cNvCxnSpPr>
+                <a:cxnSpLocks/>
+              </p:cNvCxnSpPr>
+              <p:nvPr/>
+            </p:nvCxnSpPr>
+            <p:spPr>
+              <a:xfrm flipH="1" flipV="1">
+                <a:off x="5026882" y="2243822"/>
+                <a:ext cx="1492" cy="139166"/>
+              </a:xfrm>
+              <a:prstGeom prst="line">
+                <a:avLst/>
+              </a:prstGeom>
+              <a:ln w="38100">
+                <a:solidFill>
+                  <a:schemeClr val="bg1">
+                    <a:lumMod val="50000"/>
+                  </a:schemeClr>
+                </a:solidFill>
+              </a:ln>
+            </p:spPr>
+            <p:style>
+              <a:lnRef idx="1">
+                <a:schemeClr val="dk1"/>
+              </a:lnRef>
+              <a:fillRef idx="2">
+                <a:schemeClr val="dk1"/>
+              </a:fillRef>
+              <a:effectRef idx="1">
+                <a:schemeClr val="dk1"/>
+              </a:effectRef>
+              <a:fontRef idx="minor">
+                <a:schemeClr val="dk1"/>
+              </a:fontRef>
+            </p:style>
+          </p:cxnSp>
+        </p:grpSp>
+        <p:sp>
+          <p:nvSpPr>
+            <p:cNvPr id="34" name="Oval 33">
+              <a:extLst>
+                <a:ext uri="{FF2B5EF4-FFF2-40B4-BE49-F238E27FC236}">
+                  <a16:creationId xmlns:a16="http://schemas.microsoft.com/office/drawing/2014/main" id="{FF40BF64-2FFA-C14F-B8F3-55DED7474BC8}"/>
+                </a:ext>
+              </a:extLst>
+            </p:cNvPr>
+            <p:cNvSpPr/>
+            <p:nvPr/>
+          </p:nvSpPr>
+          <p:spPr>
+            <a:xfrm>
+              <a:off x="4962692" y="2384981"/>
+              <a:ext cx="102385" cy="190269"/>
+            </a:xfrm>
+            <a:prstGeom prst="ellipse">
+              <a:avLst/>
+            </a:prstGeom>
+            <a:solidFill>
+              <a:schemeClr val="bg1">
+                <a:lumMod val="75000"/>
+              </a:schemeClr>
+            </a:solidFill>
+            <a:ln>
+              <a:solidFill>
+                <a:schemeClr val="bg1">
+                  <a:lumMod val="50000"/>
+                </a:schemeClr>
+              </a:solidFill>
+            </a:ln>
           </p:spPr>
           <p:style>
             <a:lnRef idx="2">
@@ -3680,16 +6082,16 @@
             <a:lstStyle/>
             <a:p>
               <a:pPr algn="ctr"/>
-              <a:endParaRPr lang="en-US" dirty="0"/>
+              <a:endParaRPr lang="en-US"/>
             </a:p>
           </p:txBody>
         </p:sp>
         <p:cxnSp>
           <p:nvCxnSpPr>
-            <p:cNvPr id="66" name="Straight Connector 65">
+            <p:cNvPr id="38" name="Straight Connector 37">
               <a:extLst>
                 <a:ext uri="{FF2B5EF4-FFF2-40B4-BE49-F238E27FC236}">
-                  <a16:creationId xmlns:a16="http://schemas.microsoft.com/office/drawing/2014/main" id="{50E86FE0-8E71-0341-81FE-CC16FB0DE69A}"/>
+                  <a16:creationId xmlns:a16="http://schemas.microsoft.com/office/drawing/2014/main" id="{6F19C48B-BB6C-A347-87C3-1114B38B6D40}"/>
                 </a:ext>
               </a:extLst>
             </p:cNvPr>
@@ -3699,18 +6101,17 @@
             <p:nvPr/>
           </p:nvCxnSpPr>
           <p:spPr>
-            <a:xfrm rot="18900000" flipH="1">
-              <a:off x="7314320" y="2455077"/>
-              <a:ext cx="0" cy="794875"/>
+            <a:xfrm>
+              <a:off x="5026882" y="2492909"/>
+              <a:ext cx="10823" cy="1367115"/>
             </a:xfrm>
             <a:prstGeom prst="line">
               <a:avLst/>
             </a:prstGeom>
-            <a:ln w="28575">
+            <a:ln w="38100">
               <a:solidFill>
-                <a:schemeClr val="tx1"/>
+                <a:srgbClr val="FFFF00"/>
               </a:solidFill>
-              <a:prstDash val="dash"/>
             </a:ln>
           </p:spPr>
           <p:style>
@@ -3729,590 +6130,10 @@
           </p:style>
         </p:cxnSp>
       </p:grpSp>
-      <p:sp>
-        <p:nvSpPr>
-          <p:cNvPr id="30" name="Arc 29">
-            <a:extLst>
-              <a:ext uri="{FF2B5EF4-FFF2-40B4-BE49-F238E27FC236}">
-                <a16:creationId xmlns:a16="http://schemas.microsoft.com/office/drawing/2014/main" id="{0BB0597D-6B72-564B-9154-969A13A0FD48}"/>
-              </a:ext>
-            </a:extLst>
-          </p:cNvPr>
-          <p:cNvSpPr/>
-          <p:nvPr/>
-        </p:nvSpPr>
-        <p:spPr>
-          <a:xfrm rot="8001389">
-            <a:off x="4634897" y="2281145"/>
-            <a:ext cx="398282" cy="545728"/>
-          </a:xfrm>
-          <a:prstGeom prst="arc">
-            <a:avLst/>
-          </a:prstGeom>
-          <a:ln w="28575">
-            <a:solidFill>
-              <a:schemeClr val="tx1"/>
-            </a:solidFill>
-            <a:prstDash val="dash"/>
-          </a:ln>
-        </p:spPr>
-        <p:style>
-          <a:lnRef idx="1">
-            <a:schemeClr val="accent1"/>
-          </a:lnRef>
-          <a:fillRef idx="0">
-            <a:schemeClr val="accent1"/>
-          </a:fillRef>
-          <a:effectRef idx="0">
-            <a:schemeClr val="accent1"/>
-          </a:effectRef>
-          <a:fontRef idx="minor">
-            <a:schemeClr val="tx1"/>
-          </a:fontRef>
-        </p:style>
-        <p:txBody>
-          <a:bodyPr rtlCol="0" anchor="ctr"/>
-          <a:lstStyle/>
-          <a:p>
-            <a:pPr algn="ctr"/>
-            <a:endParaRPr lang="en-US"/>
-          </a:p>
-        </p:txBody>
-      </p:sp>
-      <p:sp>
-        <p:nvSpPr>
-          <p:cNvPr id="32" name="Rectangle 31">
-            <a:extLst>
-              <a:ext uri="{FF2B5EF4-FFF2-40B4-BE49-F238E27FC236}">
-                <a16:creationId xmlns:a16="http://schemas.microsoft.com/office/drawing/2014/main" id="{CF8B86DC-52DB-6341-A749-C3C4243F319E}"/>
-              </a:ext>
-            </a:extLst>
-          </p:cNvPr>
-          <p:cNvSpPr/>
-          <p:nvPr/>
-        </p:nvSpPr>
-        <p:spPr>
-          <a:xfrm>
-            <a:off x="5676717" y="1989054"/>
-            <a:ext cx="1305235" cy="1300909"/>
-          </a:xfrm>
-          <a:prstGeom prst="rect">
-            <a:avLst/>
-          </a:prstGeom>
-          <a:noFill/>
-          <a:ln>
-            <a:solidFill>
-              <a:schemeClr val="bg1">
-                <a:lumMod val="85000"/>
-              </a:schemeClr>
-            </a:solidFill>
-          </a:ln>
-        </p:spPr>
-        <p:style>
-          <a:lnRef idx="2">
-            <a:schemeClr val="accent1">
-              <a:shade val="50000"/>
-            </a:schemeClr>
-          </a:lnRef>
-          <a:fillRef idx="1">
-            <a:schemeClr val="accent1"/>
-          </a:fillRef>
-          <a:effectRef idx="0">
-            <a:schemeClr val="accent1"/>
-          </a:effectRef>
-          <a:fontRef idx="minor">
-            <a:schemeClr val="lt1"/>
-          </a:fontRef>
-        </p:style>
-        <p:txBody>
-          <a:bodyPr rtlCol="0" anchor="ctr"/>
-          <a:lstStyle/>
-          <a:p>
-            <a:pPr algn="ctr"/>
-            <a:endParaRPr lang="en-US"/>
-          </a:p>
-        </p:txBody>
-      </p:sp>
-      <p:grpSp>
-        <p:nvGrpSpPr>
-          <p:cNvPr id="18" name="Group 17">
-            <a:extLst>
-              <a:ext uri="{FF2B5EF4-FFF2-40B4-BE49-F238E27FC236}">
-                <a16:creationId xmlns:a16="http://schemas.microsoft.com/office/drawing/2014/main" id="{019EDFD7-420F-604D-B24D-5469DD77AE9B}"/>
-              </a:ext>
-            </a:extLst>
-          </p:cNvPr>
-          <p:cNvGrpSpPr/>
-          <p:nvPr/>
-        </p:nvGrpSpPr>
-        <p:grpSpPr>
-          <a:xfrm>
-            <a:off x="5645503" y="2251236"/>
-            <a:ext cx="1403050" cy="1057913"/>
-            <a:chOff x="5645503" y="2263428"/>
-            <a:chExt cx="1403050" cy="1057913"/>
-          </a:xfrm>
-        </p:grpSpPr>
-        <p:grpSp>
-          <p:nvGrpSpPr>
-            <p:cNvPr id="17" name="Group 16">
-              <a:extLst>
-                <a:ext uri="{FF2B5EF4-FFF2-40B4-BE49-F238E27FC236}">
-                  <a16:creationId xmlns:a16="http://schemas.microsoft.com/office/drawing/2014/main" id="{8A51DF10-22D3-664B-849A-B96A7B3D4350}"/>
-                </a:ext>
-              </a:extLst>
-            </p:cNvPr>
-            <p:cNvGrpSpPr/>
-            <p:nvPr/>
-          </p:nvGrpSpPr>
-          <p:grpSpPr>
-            <a:xfrm>
-              <a:off x="5645503" y="2398011"/>
-              <a:ext cx="1403050" cy="832920"/>
-              <a:chOff x="5682959" y="2430398"/>
-              <a:chExt cx="1403050" cy="832920"/>
-            </a:xfrm>
-          </p:grpSpPr>
-          <p:cxnSp>
-            <p:nvCxnSpPr>
-              <p:cNvPr id="34" name="Straight Connector 33">
-                <a:extLst>
-                  <a:ext uri="{FF2B5EF4-FFF2-40B4-BE49-F238E27FC236}">
-                    <a16:creationId xmlns:a16="http://schemas.microsoft.com/office/drawing/2014/main" id="{C1410969-735C-694E-B831-939487DDDB06}"/>
-                  </a:ext>
-                </a:extLst>
-              </p:cNvPr>
-              <p:cNvCxnSpPr>
-                <a:cxnSpLocks/>
-              </p:cNvCxnSpPr>
-              <p:nvPr/>
-            </p:nvCxnSpPr>
-            <p:spPr>
-              <a:xfrm flipH="1">
-                <a:off x="5851470" y="2615124"/>
-                <a:ext cx="360000" cy="0"/>
-              </a:xfrm>
-              <a:prstGeom prst="line">
-                <a:avLst/>
-              </a:prstGeom>
-              <a:ln w="28575">
-                <a:solidFill>
-                  <a:srgbClr val="FF0000"/>
-                </a:solidFill>
-                <a:prstDash val="solid"/>
-              </a:ln>
-            </p:spPr>
-            <p:style>
-              <a:lnRef idx="1">
-                <a:schemeClr val="accent1"/>
-              </a:lnRef>
-              <a:fillRef idx="0">
-                <a:schemeClr val="accent1"/>
-              </a:fillRef>
-              <a:effectRef idx="0">
-                <a:schemeClr val="accent1"/>
-              </a:effectRef>
-              <a:fontRef idx="minor">
-                <a:schemeClr val="tx1"/>
-              </a:fontRef>
-            </p:style>
-          </p:cxnSp>
-          <p:cxnSp>
-            <p:nvCxnSpPr>
-              <p:cNvPr id="37" name="Straight Connector 36">
-                <a:extLst>
-                  <a:ext uri="{FF2B5EF4-FFF2-40B4-BE49-F238E27FC236}">
-                    <a16:creationId xmlns:a16="http://schemas.microsoft.com/office/drawing/2014/main" id="{42C5F916-DAA3-BF4C-B0A3-D37EEE3A92A8}"/>
-                  </a:ext>
-                </a:extLst>
-              </p:cNvPr>
-              <p:cNvCxnSpPr>
-                <a:cxnSpLocks/>
-              </p:cNvCxnSpPr>
-              <p:nvPr/>
-            </p:nvCxnSpPr>
-            <p:spPr>
-              <a:xfrm flipV="1">
-                <a:off x="6223671" y="2600201"/>
-                <a:ext cx="0" cy="360000"/>
-              </a:xfrm>
-              <a:prstGeom prst="line">
-                <a:avLst/>
-              </a:prstGeom>
-              <a:ln w="28575">
-                <a:solidFill>
-                  <a:schemeClr val="tx1"/>
-                </a:solidFill>
-                <a:prstDash val="solid"/>
-              </a:ln>
-            </p:spPr>
-            <p:style>
-              <a:lnRef idx="1">
-                <a:schemeClr val="accent1"/>
-              </a:lnRef>
-              <a:fillRef idx="0">
-                <a:schemeClr val="accent1"/>
-              </a:fillRef>
-              <a:effectRef idx="0">
-                <a:schemeClr val="accent1"/>
-              </a:effectRef>
-              <a:fontRef idx="minor">
-                <a:schemeClr val="tx1"/>
-              </a:fontRef>
-            </p:style>
-          </p:cxnSp>
-          <p:sp>
-            <p:nvSpPr>
-              <p:cNvPr id="12" name="TextBox 11">
-                <a:extLst>
-                  <a:ext uri="{FF2B5EF4-FFF2-40B4-BE49-F238E27FC236}">
-                    <a16:creationId xmlns:a16="http://schemas.microsoft.com/office/drawing/2014/main" id="{F0E1D980-FDE6-764E-AC6B-7A917BE198E2}"/>
-                  </a:ext>
-                </a:extLst>
-              </p:cNvPr>
-              <p:cNvSpPr txBox="1"/>
-              <p:nvPr/>
-            </p:nvSpPr>
-            <p:spPr>
-              <a:xfrm>
-                <a:off x="6024824" y="2893986"/>
-                <a:ext cx="418704" cy="369332"/>
-              </a:xfrm>
-              <a:prstGeom prst="rect">
-                <a:avLst/>
-              </a:prstGeom>
-              <a:noFill/>
-            </p:spPr>
-            <p:txBody>
-              <a:bodyPr wrap="none" rtlCol="0">
-                <a:spAutoFit/>
-              </a:bodyPr>
-              <a:lstStyle/>
-              <a:p>
-                <a:r>
-                  <a:rPr lang="en-US" dirty="0"/>
-                  <a:t>90</a:t>
-                </a:r>
-              </a:p>
-            </p:txBody>
-          </p:sp>
-          <p:cxnSp>
-            <p:nvCxnSpPr>
-              <p:cNvPr id="41" name="Straight Connector 40">
-                <a:extLst>
-                  <a:ext uri="{FF2B5EF4-FFF2-40B4-BE49-F238E27FC236}">
-                    <a16:creationId xmlns:a16="http://schemas.microsoft.com/office/drawing/2014/main" id="{9E35AE0E-BD74-FB43-83C0-B38D20C2F6CF}"/>
-                  </a:ext>
-                </a:extLst>
-              </p:cNvPr>
-              <p:cNvCxnSpPr>
-                <a:cxnSpLocks/>
-              </p:cNvCxnSpPr>
-              <p:nvPr/>
-            </p:nvCxnSpPr>
-            <p:spPr>
-              <a:xfrm flipH="1">
-                <a:off x="6217920" y="2615064"/>
-                <a:ext cx="360000" cy="0"/>
-              </a:xfrm>
-              <a:prstGeom prst="line">
-                <a:avLst/>
-              </a:prstGeom>
-              <a:ln w="28575">
-                <a:solidFill>
-                  <a:schemeClr val="tx1"/>
-                </a:solidFill>
-                <a:prstDash val="solid"/>
-              </a:ln>
-            </p:spPr>
-            <p:style>
-              <a:lnRef idx="1">
-                <a:schemeClr val="accent1"/>
-              </a:lnRef>
-              <a:fillRef idx="0">
-                <a:schemeClr val="accent1"/>
-              </a:fillRef>
-              <a:effectRef idx="0">
-                <a:schemeClr val="accent1"/>
-              </a:effectRef>
-              <a:fontRef idx="minor">
-                <a:schemeClr val="tx1"/>
-              </a:fontRef>
-            </p:style>
-          </p:cxnSp>
-          <p:sp>
-            <p:nvSpPr>
-              <p:cNvPr id="42" name="TextBox 41">
-                <a:extLst>
-                  <a:ext uri="{FF2B5EF4-FFF2-40B4-BE49-F238E27FC236}">
-                    <a16:creationId xmlns:a16="http://schemas.microsoft.com/office/drawing/2014/main" id="{3880AAD5-2790-6D42-A0BB-8402E084E29A}"/>
-                  </a:ext>
-                </a:extLst>
-              </p:cNvPr>
-              <p:cNvSpPr txBox="1"/>
-              <p:nvPr/>
-            </p:nvSpPr>
-            <p:spPr>
-              <a:xfrm>
-                <a:off x="6550285" y="2430398"/>
-                <a:ext cx="535724" cy="369332"/>
-              </a:xfrm>
-              <a:prstGeom prst="rect">
-                <a:avLst/>
-              </a:prstGeom>
-              <a:noFill/>
-            </p:spPr>
-            <p:txBody>
-              <a:bodyPr wrap="none" rtlCol="0">
-                <a:spAutoFit/>
-              </a:bodyPr>
-              <a:lstStyle/>
-              <a:p>
-                <a:r>
-                  <a:rPr lang="en-US" dirty="0"/>
-                  <a:t>180</a:t>
-                </a:r>
-              </a:p>
-            </p:txBody>
-          </p:sp>
-          <p:cxnSp>
-            <p:nvCxnSpPr>
-              <p:cNvPr id="44" name="Straight Connector 43">
-                <a:extLst>
-                  <a:ext uri="{FF2B5EF4-FFF2-40B4-BE49-F238E27FC236}">
-                    <a16:creationId xmlns:a16="http://schemas.microsoft.com/office/drawing/2014/main" id="{8BD201C1-DDB2-B14F-BD6E-CBC2310E902A}"/>
-                  </a:ext>
-                </a:extLst>
-              </p:cNvPr>
-              <p:cNvCxnSpPr>
-                <a:cxnSpLocks/>
-              </p:cNvCxnSpPr>
-              <p:nvPr/>
-            </p:nvCxnSpPr>
-            <p:spPr>
-              <a:xfrm rot="2700000" flipV="1">
-                <a:off x="6088170" y="2574496"/>
-                <a:ext cx="0" cy="360000"/>
-              </a:xfrm>
-              <a:prstGeom prst="line">
-                <a:avLst/>
-              </a:prstGeom>
-              <a:ln w="28575">
-                <a:solidFill>
-                  <a:schemeClr val="tx1"/>
-                </a:solidFill>
-                <a:prstDash val="solid"/>
-              </a:ln>
-            </p:spPr>
-            <p:style>
-              <a:lnRef idx="1">
-                <a:schemeClr val="accent1"/>
-              </a:lnRef>
-              <a:fillRef idx="0">
-                <a:schemeClr val="accent1"/>
-              </a:fillRef>
-              <a:effectRef idx="0">
-                <a:schemeClr val="accent1"/>
-              </a:effectRef>
-              <a:fontRef idx="minor">
-                <a:schemeClr val="tx1"/>
-              </a:fontRef>
-            </p:style>
-          </p:cxnSp>
-          <p:sp>
-            <p:nvSpPr>
-              <p:cNvPr id="45" name="TextBox 44">
-                <a:extLst>
-                  <a:ext uri="{FF2B5EF4-FFF2-40B4-BE49-F238E27FC236}">
-                    <a16:creationId xmlns:a16="http://schemas.microsoft.com/office/drawing/2014/main" id="{DBD48DAB-5A75-4E47-B839-E5D110E14E3D}"/>
-                  </a:ext>
-                </a:extLst>
-              </p:cNvPr>
-              <p:cNvSpPr txBox="1"/>
-              <p:nvPr/>
-            </p:nvSpPr>
-            <p:spPr>
-              <a:xfrm>
-                <a:off x="5682959" y="2780201"/>
-                <a:ext cx="418704" cy="369332"/>
-              </a:xfrm>
-              <a:prstGeom prst="rect">
-                <a:avLst/>
-              </a:prstGeom>
-              <a:noFill/>
-            </p:spPr>
-            <p:txBody>
-              <a:bodyPr wrap="none" rtlCol="0">
-                <a:spAutoFit/>
-              </a:bodyPr>
-              <a:lstStyle/>
-              <a:p>
-                <a:r>
-                  <a:rPr lang="en-US" dirty="0"/>
-                  <a:t>45</a:t>
-                </a:r>
-              </a:p>
-            </p:txBody>
-          </p:sp>
-          <p:cxnSp>
-            <p:nvCxnSpPr>
-              <p:cNvPr id="46" name="Straight Connector 45">
-                <a:extLst>
-                  <a:ext uri="{FF2B5EF4-FFF2-40B4-BE49-F238E27FC236}">
-                    <a16:creationId xmlns:a16="http://schemas.microsoft.com/office/drawing/2014/main" id="{96B080D8-B1C2-BB4F-8C29-ECE21BBD4E65}"/>
-                  </a:ext>
-                </a:extLst>
-              </p:cNvPr>
-              <p:cNvCxnSpPr>
-                <a:cxnSpLocks/>
-              </p:cNvCxnSpPr>
-              <p:nvPr/>
-            </p:nvCxnSpPr>
-            <p:spPr>
-              <a:xfrm rot="18900000" flipH="1" flipV="1">
-                <a:off x="6349550" y="2571556"/>
-                <a:ext cx="0" cy="360000"/>
-              </a:xfrm>
-              <a:prstGeom prst="line">
-                <a:avLst/>
-              </a:prstGeom>
-              <a:ln w="28575">
-                <a:solidFill>
-                  <a:schemeClr val="tx1"/>
-                </a:solidFill>
-                <a:prstDash val="solid"/>
-              </a:ln>
-            </p:spPr>
-            <p:style>
-              <a:lnRef idx="1">
-                <a:schemeClr val="accent1"/>
-              </a:lnRef>
-              <a:fillRef idx="0">
-                <a:schemeClr val="accent1"/>
-              </a:fillRef>
-              <a:effectRef idx="0">
-                <a:schemeClr val="accent1"/>
-              </a:effectRef>
-              <a:fontRef idx="minor">
-                <a:schemeClr val="tx1"/>
-              </a:fontRef>
-            </p:style>
-          </p:cxnSp>
-          <p:sp>
-            <p:nvSpPr>
-              <p:cNvPr id="49" name="TextBox 48">
-                <a:extLst>
-                  <a:ext uri="{FF2B5EF4-FFF2-40B4-BE49-F238E27FC236}">
-                    <a16:creationId xmlns:a16="http://schemas.microsoft.com/office/drawing/2014/main" id="{32FEF30D-1D20-174C-BB89-A61C12708F41}"/>
-                  </a:ext>
-                </a:extLst>
-              </p:cNvPr>
-              <p:cNvSpPr txBox="1"/>
-              <p:nvPr/>
-            </p:nvSpPr>
-            <p:spPr>
-              <a:xfrm>
-                <a:off x="6399443" y="2784234"/>
-                <a:ext cx="535724" cy="369332"/>
-              </a:xfrm>
-              <a:prstGeom prst="rect">
-                <a:avLst/>
-              </a:prstGeom>
-              <a:noFill/>
-            </p:spPr>
-            <p:txBody>
-              <a:bodyPr wrap="none" rtlCol="0">
-                <a:spAutoFit/>
-              </a:bodyPr>
-              <a:lstStyle/>
-              <a:p>
-                <a:r>
-                  <a:rPr lang="en-US" dirty="0"/>
-                  <a:t>135</a:t>
-                </a:r>
-              </a:p>
-            </p:txBody>
-          </p:sp>
-        </p:grpSp>
-        <p:sp>
-          <p:nvSpPr>
-            <p:cNvPr id="50" name="TextBox 49">
-              <a:extLst>
-                <a:ext uri="{FF2B5EF4-FFF2-40B4-BE49-F238E27FC236}">
-                  <a16:creationId xmlns:a16="http://schemas.microsoft.com/office/drawing/2014/main" id="{8A12FA53-DCD5-0C4F-8629-0DA5EBF8EA85}"/>
-                </a:ext>
-              </a:extLst>
-            </p:cNvPr>
-            <p:cNvSpPr txBox="1"/>
-            <p:nvPr/>
-          </p:nvSpPr>
-          <p:spPr>
-            <a:xfrm>
-              <a:off x="5728668" y="2263428"/>
-              <a:ext cx="498406" cy="369332"/>
-            </a:xfrm>
-            <a:prstGeom prst="rect">
-              <a:avLst/>
-            </a:prstGeom>
-            <a:noFill/>
-          </p:spPr>
-          <p:txBody>
-            <a:bodyPr wrap="none" rtlCol="0">
-              <a:spAutoFit/>
-            </a:bodyPr>
-            <a:lstStyle/>
-            <a:p>
-              <a:r>
-                <a:rPr lang="en-US" dirty="0">
-                  <a:solidFill>
-                    <a:srgbClr val="FF0000"/>
-                  </a:solidFill>
-                </a:rPr>
-                <a:t>left</a:t>
-              </a:r>
-            </a:p>
-          </p:txBody>
-        </p:sp>
-        <p:sp>
-          <p:nvSpPr>
-            <p:cNvPr id="67" name="TextBox 66">
-              <a:extLst>
-                <a:ext uri="{FF2B5EF4-FFF2-40B4-BE49-F238E27FC236}">
-                  <a16:creationId xmlns:a16="http://schemas.microsoft.com/office/drawing/2014/main" id="{45E93BD0-403E-7C44-ACC4-B00592A9B16E}"/>
-                </a:ext>
-              </a:extLst>
-            </p:cNvPr>
-            <p:cNvSpPr txBox="1"/>
-            <p:nvPr/>
-          </p:nvSpPr>
-          <p:spPr>
-            <a:xfrm>
-              <a:off x="6308319" y="2952009"/>
-              <a:ext cx="623376" cy="369332"/>
-            </a:xfrm>
-            <a:prstGeom prst="rect">
-              <a:avLst/>
-            </a:prstGeom>
-            <a:noFill/>
-          </p:spPr>
-          <p:txBody>
-            <a:bodyPr wrap="none" rtlCol="0">
-              <a:spAutoFit/>
-            </a:bodyPr>
-            <a:lstStyle/>
-            <a:p>
-              <a:r>
-                <a:rPr lang="en-US" dirty="0"/>
-                <a:t>right</a:t>
-              </a:r>
-            </a:p>
-          </p:txBody>
-        </p:sp>
-      </p:grpSp>
     </p:spTree>
     <p:extLst>
       <p:ext uri="{BB962C8B-B14F-4D97-AF65-F5344CB8AC3E}">
-        <p14:creationId xmlns:p14="http://schemas.microsoft.com/office/powerpoint/2010/main" val="3225664317"/>
+        <p14:creationId xmlns:p14="http://schemas.microsoft.com/office/powerpoint/2010/main" val="1779690495"/>
       </p:ext>
     </p:extLst>
   </p:cSld>

</xml_diff>

<commit_message>
Make button colors match ruler colors.
</commit_message>
<xml_diff>
--- a/limb_position.pptx
+++ b/limb_position.pptx
@@ -3945,7 +3945,7 @@
             </a:prstGeom>
             <a:ln w="38100">
               <a:solidFill>
-                <a:srgbClr val="00B050"/>
+                <a:srgbClr val="00FF00"/>
               </a:solidFill>
             </a:ln>
           </p:spPr>
@@ -4611,7 +4611,7 @@
             </a:prstGeom>
             <a:ln w="38100">
               <a:solidFill>
-                <a:schemeClr val="accent1"/>
+                <a:srgbClr val="00FFFF"/>
               </a:solidFill>
             </a:ln>
           </p:spPr>
@@ -5898,92 +5898,6 @@
           </p:cxnSp>
           <p:cxnSp>
             <p:nvCxnSpPr>
-              <p:cNvPr id="72" name="Straight Connector 71">
-                <a:extLst>
-                  <a:ext uri="{FF2B5EF4-FFF2-40B4-BE49-F238E27FC236}">
-                    <a16:creationId xmlns:a16="http://schemas.microsoft.com/office/drawing/2014/main" id="{FC1B5090-4092-4145-BF1A-DED9FEF6618F}"/>
-                  </a:ext>
-                </a:extLst>
-              </p:cNvPr>
-              <p:cNvCxnSpPr>
-                <a:cxnSpLocks/>
-              </p:cNvCxnSpPr>
-              <p:nvPr/>
-            </p:nvCxnSpPr>
-            <p:spPr>
-              <a:xfrm>
-                <a:off x="4933488" y="3469736"/>
-                <a:ext cx="101154" cy="65947"/>
-              </a:xfrm>
-              <a:prstGeom prst="line">
-                <a:avLst/>
-              </a:prstGeom>
-              <a:ln w="38100">
-                <a:solidFill>
-                  <a:schemeClr val="bg1"/>
-                </a:solidFill>
-              </a:ln>
-            </p:spPr>
-            <p:style>
-              <a:lnRef idx="1">
-                <a:schemeClr val="accent1"/>
-              </a:lnRef>
-              <a:fillRef idx="0">
-                <a:schemeClr val="accent1"/>
-              </a:fillRef>
-              <a:effectRef idx="0">
-                <a:schemeClr val="accent1"/>
-              </a:effectRef>
-              <a:fontRef idx="minor">
-                <a:schemeClr val="tx1"/>
-              </a:fontRef>
-            </p:style>
-          </p:cxnSp>
-          <p:cxnSp>
-            <p:nvCxnSpPr>
-              <p:cNvPr id="75" name="Straight Connector 74">
-                <a:extLst>
-                  <a:ext uri="{FF2B5EF4-FFF2-40B4-BE49-F238E27FC236}">
-                    <a16:creationId xmlns:a16="http://schemas.microsoft.com/office/drawing/2014/main" id="{25B56C43-9DDC-2E43-8BED-179D4E652E41}"/>
-                  </a:ext>
-                </a:extLst>
-              </p:cNvPr>
-              <p:cNvCxnSpPr>
-                <a:cxnSpLocks/>
-              </p:cNvCxnSpPr>
-              <p:nvPr/>
-            </p:nvCxnSpPr>
-            <p:spPr>
-              <a:xfrm flipH="1">
-                <a:off x="5034642" y="3469735"/>
-                <a:ext cx="101154" cy="65947"/>
-              </a:xfrm>
-              <a:prstGeom prst="line">
-                <a:avLst/>
-              </a:prstGeom>
-              <a:ln w="38100">
-                <a:solidFill>
-                  <a:schemeClr val="bg1"/>
-                </a:solidFill>
-              </a:ln>
-            </p:spPr>
-            <p:style>
-              <a:lnRef idx="1">
-                <a:schemeClr val="accent1"/>
-              </a:lnRef>
-              <a:fillRef idx="0">
-                <a:schemeClr val="accent1"/>
-              </a:fillRef>
-              <a:effectRef idx="0">
-                <a:schemeClr val="accent1"/>
-              </a:effectRef>
-              <a:fontRef idx="minor">
-                <a:schemeClr val="tx1"/>
-              </a:fontRef>
-            </p:style>
-          </p:cxnSp>
-          <p:cxnSp>
-            <p:nvCxnSpPr>
               <p:cNvPr id="91" name="Straight Connector 90">
                 <a:extLst>
                   <a:ext uri="{FF2B5EF4-FFF2-40B4-BE49-F238E27FC236}">
@@ -6042,7 +5956,7 @@
           </p:nvSpPr>
           <p:spPr>
             <a:xfrm>
-              <a:off x="4962692" y="2384981"/>
+              <a:off x="4969099" y="2384980"/>
               <a:ext cx="102385" cy="190269"/>
             </a:xfrm>
             <a:prstGeom prst="ellipse">

</xml_diff>